<commit_message>
Slides: clearer Input-System-Output page
</commit_message>
<xml_diff>
--- a/docs/slides_revised_topic.pptx
+++ b/docs/slides_revised_topic.pptx
@@ -9167,40 +9167,254 @@
           </a:p>
         </p:txBody>
       </p:sp>
-      <p:pic>
-        <p:nvPicPr>
-          <p:cNvPr id="7" name="Picture 6" descr="system.png"/>
-          <p:cNvPicPr>
-            <a:picLocks noChangeAspect="1"/>
-          </p:cNvPicPr>
-          <p:nvPr/>
-        </p:nvPicPr>
-        <p:blipFill>
-          <a:blip r:embed="rId3"/>
-          <a:stretch>
-            <a:fillRect/>
-          </a:stretch>
-        </p:blipFill>
-        <p:spPr>
-          <a:xfrm>
-            <a:off x="1587599" y="1655999"/>
-            <a:ext cx="9360000" cy="2704380"/>
-          </a:xfrm>
-          <a:prstGeom prst="rect">
-            <a:avLst/>
-          </a:prstGeom>
-        </p:spPr>
-      </p:pic>
-      <p:sp>
-        <p:nvSpPr>
-          <p:cNvPr id="8" name="Rounded Rectangle 7"/>
+      <p:sp>
+        <p:nvSpPr>
+          <p:cNvPr id="7" name="Rounded Rectangle 6"/>
           <p:cNvSpPr/>
           <p:nvPr/>
         </p:nvSpPr>
         <p:spPr>
           <a:xfrm>
-            <a:off x="813599" y="4428000"/>
-            <a:ext cx="3528000" cy="1188000"/>
+            <a:off x="813599" y="2015999"/>
+            <a:ext cx="2196000" cy="2088000"/>
+          </a:xfrm>
+          <a:prstGeom prst="roundRect">
+            <a:avLst>
+              <a:gd name="adj" fmla="val 6000"/>
+            </a:avLst>
+          </a:prstGeom>
+          <a:solidFill>
+            <a:srgbClr val="D5DBE4"/>
+          </a:solidFill>
+          <a:ln>
+            <a:noFill/>
+          </a:ln>
+          <a:effectLst/>
+        </p:spPr>
+        <p:style>
+          <a:lnRef idx="1">
+            <a:schemeClr val="accent1"/>
+          </a:lnRef>
+          <a:fillRef idx="3">
+            <a:schemeClr val="accent1"/>
+          </a:fillRef>
+          <a:effectRef idx="2">
+            <a:schemeClr val="accent1"/>
+          </a:effectRef>
+          <a:fontRef idx="minor">
+            <a:schemeClr val="lt1"/>
+          </a:fontRef>
+        </p:style>
+        <p:txBody>
+          <a:bodyPr rtlCol="0" anchor="ctr"/>
+          <a:lstStyle/>
+          <a:p>
+            <a:pPr algn="ctr"/>
+          </a:p>
+        </p:txBody>
+      </p:sp>
+      <p:sp>
+        <p:nvSpPr>
+          <p:cNvPr id="8" name="TextBox 7"/>
+          <p:cNvSpPr txBox="1"/>
+          <p:nvPr/>
+        </p:nvSpPr>
+        <p:spPr>
+          <a:xfrm>
+            <a:off x="957599" y="2123999"/>
+            <a:ext cx="1944000" cy="360000"/>
+          </a:xfrm>
+          <a:prstGeom prst="rect">
+            <a:avLst/>
+          </a:prstGeom>
+          <a:noFill/>
+        </p:spPr>
+        <p:txBody>
+          <a:bodyPr wrap="square">
+            <a:spAutoFit/>
+          </a:bodyPr>
+          <a:lstStyle/>
+          <a:p>
+            <a:pPr>
+              <a:spcAft>
+                <a:spcPts val="400"/>
+              </a:spcAft>
+            </a:pPr>
+            <a:r>
+              <a:rPr sz="1500" b="1">
+                <a:solidFill>
+                  <a:srgbClr val="14213D"/>
+                </a:solidFill>
+                <a:latin typeface="Arial"/>
+              </a:rPr>
+              <a:t>On the line today</a:t>
+            </a:r>
+          </a:p>
+        </p:txBody>
+      </p:sp>
+      <p:sp>
+        <p:nvSpPr>
+          <p:cNvPr id="9" name="TextBox 8"/>
+          <p:cNvSpPr txBox="1"/>
+          <p:nvPr/>
+        </p:nvSpPr>
+        <p:spPr>
+          <a:xfrm>
+            <a:off x="957599" y="2519998"/>
+            <a:ext cx="1944000" cy="1512000"/>
+          </a:xfrm>
+          <a:prstGeom prst="rect">
+            <a:avLst/>
+          </a:prstGeom>
+          <a:noFill/>
+        </p:spPr>
+        <p:txBody>
+          <a:bodyPr wrap="square">
+            <a:spAutoFit/>
+          </a:bodyPr>
+          <a:lstStyle/>
+          <a:p>
+            <a:pPr>
+              <a:spcAft>
+                <a:spcPts val="400"/>
+              </a:spcAft>
+            </a:pPr>
+            <a:r>
+              <a:rPr sz="1300" b="0">
+                <a:solidFill>
+                  <a:srgbClr val="14213D"/>
+                </a:solidFill>
+                <a:latin typeface="Arial"/>
+              </a:rPr>
+              <a:t>SMT soldering</a:t>
+            </a:r>
+          </a:p>
+          <a:p>
+            <a:pPr>
+              <a:spcAft>
+                <a:spcPts val="400"/>
+              </a:spcAft>
+            </a:pPr>
+            <a:r>
+              <a:rPr sz="1300" b="0">
+                <a:solidFill>
+                  <a:srgbClr val="14213D"/>
+                </a:solidFill>
+                <a:latin typeface="Arial"/>
+              </a:rPr>
+              <a:t>AOI camera checks every joint against fixed limits</a:t>
+            </a:r>
+          </a:p>
+          <a:p>
+            <a:pPr>
+              <a:spcAft>
+                <a:spcPts val="400"/>
+              </a:spcAft>
+            </a:pPr>
+            <a:r>
+              <a:rPr sz="1300" b="0">
+                <a:solidFill>
+                  <a:srgbClr val="14213D"/>
+                </a:solidFill>
+                <a:latin typeface="Arial"/>
+              </a:rPr>
+              <a:t>Flags suspicious boards</a:t>
+            </a:r>
+          </a:p>
+        </p:txBody>
+      </p:sp>
+      <p:sp>
+        <p:nvSpPr>
+          <p:cNvPr id="10" name="Right Arrow 9"/>
+          <p:cNvSpPr/>
+          <p:nvPr/>
+        </p:nvSpPr>
+        <p:spPr>
+          <a:xfrm>
+            <a:off x="3063599" y="2915999"/>
+            <a:ext cx="270000" cy="288000"/>
+          </a:xfrm>
+          <a:prstGeom prst="rightArrow">
+            <a:avLst/>
+          </a:prstGeom>
+          <a:solidFill>
+            <a:srgbClr val="2F6DB5"/>
+          </a:solidFill>
+          <a:ln>
+            <a:noFill/>
+          </a:ln>
+        </p:spPr>
+        <p:style>
+          <a:lnRef idx="1">
+            <a:schemeClr val="accent1"/>
+          </a:lnRef>
+          <a:fillRef idx="3">
+            <a:schemeClr val="accent1"/>
+          </a:fillRef>
+          <a:effectRef idx="2">
+            <a:schemeClr val="accent1"/>
+          </a:effectRef>
+          <a:fontRef idx="minor">
+            <a:schemeClr val="lt1"/>
+          </a:fontRef>
+        </p:style>
+        <p:txBody>
+          <a:bodyPr rtlCol="0" anchor="ctr"/>
+          <a:lstStyle/>
+          <a:p>
+            <a:pPr algn="ctr"/>
+          </a:p>
+        </p:txBody>
+      </p:sp>
+      <p:sp>
+        <p:nvSpPr>
+          <p:cNvPr id="11" name="TextBox 10"/>
+          <p:cNvSpPr txBox="1"/>
+          <p:nvPr/>
+        </p:nvSpPr>
+        <p:spPr>
+          <a:xfrm>
+            <a:off x="3387599" y="1710000"/>
+            <a:ext cx="2304000" cy="288000"/>
+          </a:xfrm>
+          <a:prstGeom prst="rect">
+            <a:avLst/>
+          </a:prstGeom>
+          <a:noFill/>
+        </p:spPr>
+        <p:txBody>
+          <a:bodyPr wrap="square">
+            <a:spAutoFit/>
+          </a:bodyPr>
+          <a:lstStyle/>
+          <a:p>
+            <a:pPr>
+              <a:spcAft>
+                <a:spcPts val="400"/>
+              </a:spcAft>
+            </a:pPr>
+            <a:r>
+              <a:rPr sz="1200" b="1">
+                <a:solidFill>
+                  <a:srgbClr val="2F6DB5"/>
+                </a:solidFill>
+                <a:latin typeface="Arial"/>
+              </a:rPr>
+              <a:t>INPUT</a:t>
+            </a:r>
+          </a:p>
+        </p:txBody>
+      </p:sp>
+      <p:sp>
+        <p:nvSpPr>
+          <p:cNvPr id="12" name="Rounded Rectangle 11"/>
+          <p:cNvSpPr/>
+          <p:nvPr/>
+        </p:nvSpPr>
+        <p:spPr>
+          <a:xfrm>
+            <a:off x="3387599" y="2015999"/>
+            <a:ext cx="2304000" cy="2088000"/>
           </a:xfrm>
           <a:prstGeom prst="roundRect">
             <a:avLst>
@@ -9239,14 +9453,14 @@
       </p:sp>
       <p:sp>
         <p:nvSpPr>
-          <p:cNvPr id="9" name="TextBox 8"/>
-          <p:cNvSpPr txBox="1"/>
-          <p:nvPr/>
-        </p:nvSpPr>
-        <p:spPr>
-          <a:xfrm>
-            <a:off x="993599" y="4553999"/>
-            <a:ext cx="3168000" cy="360000"/>
+          <p:cNvPr id="13" name="TextBox 12"/>
+          <p:cNvSpPr txBox="1"/>
+          <p:nvPr/>
+        </p:nvSpPr>
+        <p:spPr>
+          <a:xfrm>
+            <a:off x="3531599" y="2123999"/>
+            <a:ext cx="2088000" cy="360000"/>
           </a:xfrm>
           <a:prstGeom prst="rect">
             <a:avLst/>
@@ -9271,21 +9485,21 @@
                 </a:solidFill>
                 <a:latin typeface="Arial"/>
               </a:rPr>
-              <a:t>Input</a:t>
-            </a:r>
-          </a:p>
-        </p:txBody>
-      </p:sp>
-      <p:sp>
-        <p:nvSpPr>
-          <p:cNvPr id="10" name="TextBox 9"/>
-          <p:cNvSpPr txBox="1"/>
-          <p:nvPr/>
-        </p:nvSpPr>
-        <p:spPr>
-          <a:xfrm>
-            <a:off x="993599" y="4878000"/>
-            <a:ext cx="3168000" cy="648000"/>
+              <a:t>AOI data per board</a:t>
+            </a:r>
+          </a:p>
+        </p:txBody>
+      </p:sp>
+      <p:sp>
+        <p:nvSpPr>
+          <p:cNvPr id="14" name="TextBox 13"/>
+          <p:cNvSpPr txBox="1"/>
+          <p:nvPr/>
+        </p:nvSpPr>
+        <p:spPr>
+          <a:xfrm>
+            <a:off x="3531599" y="2519998"/>
+            <a:ext cx="2088000" cy="1512000"/>
           </a:xfrm>
           <a:prstGeom prst="rect">
             <a:avLst/>
@@ -9304,27 +9518,157 @@
               </a:spcAft>
             </a:pPr>
             <a:r>
-              <a:rPr sz="1200" b="0">
+              <a:rPr sz="1300" b="0">
                 <a:solidFill>
                   <a:srgbClr val="14213D"/>
                 </a:solidFill>
                 <a:latin typeface="Arial"/>
               </a:rPr>
-              <a:t>AOI measurements of each flagged joint (~70 values), inspection type, component type, error code</a:t>
-            </a:r>
-          </a:p>
-        </p:txBody>
-      </p:sp>
-      <p:sp>
-        <p:nvSpPr>
-          <p:cNvPr id="11" name="Rounded Rectangle 10"/>
+              <a:t>~70 measurements per joint</a:t>
+            </a:r>
+          </a:p>
+          <a:p>
+            <a:pPr>
+              <a:spcAft>
+                <a:spcPts val="400"/>
+              </a:spcAft>
+            </a:pPr>
+            <a:r>
+              <a:rPr sz="1300" b="0">
+                <a:solidFill>
+                  <a:srgbClr val="14213D"/>
+                </a:solidFill>
+                <a:latin typeface="Arial"/>
+              </a:rPr>
+              <a:t>Inspection type</a:t>
+            </a:r>
+          </a:p>
+          <a:p>
+            <a:pPr>
+              <a:spcAft>
+                <a:spcPts val="400"/>
+              </a:spcAft>
+            </a:pPr>
+            <a:r>
+              <a:rPr sz="1300" b="0">
+                <a:solidFill>
+                  <a:srgbClr val="14213D"/>
+                </a:solidFill>
+                <a:latin typeface="Arial"/>
+              </a:rPr>
+              <a:t>Component type</a:t>
+            </a:r>
+          </a:p>
+          <a:p>
+            <a:pPr>
+              <a:spcAft>
+                <a:spcPts val="400"/>
+              </a:spcAft>
+            </a:pPr>
+            <a:r>
+              <a:rPr sz="1300" b="0">
+                <a:solidFill>
+                  <a:srgbClr val="14213D"/>
+                </a:solidFill>
+                <a:latin typeface="Arial"/>
+              </a:rPr>
+              <a:t>AOI error code</a:t>
+            </a:r>
+          </a:p>
+        </p:txBody>
+      </p:sp>
+      <p:sp>
+        <p:nvSpPr>
+          <p:cNvPr id="15" name="Right Arrow 14"/>
           <p:cNvSpPr/>
           <p:nvPr/>
         </p:nvSpPr>
         <p:spPr>
           <a:xfrm>
-            <a:off x="4503599" y="4428000"/>
-            <a:ext cx="3528000" cy="1188000"/>
+            <a:off x="5745599" y="2915999"/>
+            <a:ext cx="270000" cy="288000"/>
+          </a:xfrm>
+          <a:prstGeom prst="rightArrow">
+            <a:avLst/>
+          </a:prstGeom>
+          <a:solidFill>
+            <a:srgbClr val="2F6DB5"/>
+          </a:solidFill>
+          <a:ln>
+            <a:noFill/>
+          </a:ln>
+        </p:spPr>
+        <p:style>
+          <a:lnRef idx="1">
+            <a:schemeClr val="accent1"/>
+          </a:lnRef>
+          <a:fillRef idx="3">
+            <a:schemeClr val="accent1"/>
+          </a:fillRef>
+          <a:effectRef idx="2">
+            <a:schemeClr val="accent1"/>
+          </a:effectRef>
+          <a:fontRef idx="minor">
+            <a:schemeClr val="lt1"/>
+          </a:fontRef>
+        </p:style>
+        <p:txBody>
+          <a:bodyPr rtlCol="0" anchor="ctr"/>
+          <a:lstStyle/>
+          <a:p>
+            <a:pPr algn="ctr"/>
+          </a:p>
+        </p:txBody>
+      </p:sp>
+      <p:sp>
+        <p:nvSpPr>
+          <p:cNvPr id="16" name="TextBox 15"/>
+          <p:cNvSpPr txBox="1"/>
+          <p:nvPr/>
+        </p:nvSpPr>
+        <p:spPr>
+          <a:xfrm>
+            <a:off x="6069599" y="1710000"/>
+            <a:ext cx="2664000" cy="288000"/>
+          </a:xfrm>
+          <a:prstGeom prst="rect">
+            <a:avLst/>
+          </a:prstGeom>
+          <a:noFill/>
+        </p:spPr>
+        <p:txBody>
+          <a:bodyPr wrap="square">
+            <a:spAutoFit/>
+          </a:bodyPr>
+          <a:lstStyle/>
+          <a:p>
+            <a:pPr>
+              <a:spcAft>
+                <a:spcPts val="400"/>
+              </a:spcAft>
+            </a:pPr>
+            <a:r>
+              <a:rPr sz="1200" b="1">
+                <a:solidFill>
+                  <a:srgbClr val="2F6DB5"/>
+                </a:solidFill>
+                <a:latin typeface="Arial"/>
+              </a:rPr>
+              <a:t>SYSTEM (OURS)</a:t>
+            </a:r>
+          </a:p>
+        </p:txBody>
+      </p:sp>
+      <p:sp>
+        <p:nvSpPr>
+          <p:cNvPr id="17" name="Rounded Rectangle 16"/>
+          <p:cNvSpPr/>
+          <p:nvPr/>
+        </p:nvSpPr>
+        <p:spPr>
+          <a:xfrm>
+            <a:off x="6069599" y="2015999"/>
+            <a:ext cx="2664000" cy="2088000"/>
           </a:xfrm>
           <a:prstGeom prst="roundRect">
             <a:avLst>
@@ -9333,6 +9677,273 @@
           </a:prstGeom>
           <a:solidFill>
             <a:srgbClr val="DCE7F5"/>
+          </a:solidFill>
+          <a:ln w="19050">
+            <a:solidFill>
+              <a:srgbClr val="2F6DB5"/>
+            </a:solidFill>
+          </a:ln>
+          <a:effectLst/>
+        </p:spPr>
+        <p:style>
+          <a:lnRef idx="1">
+            <a:schemeClr val="accent1"/>
+          </a:lnRef>
+          <a:fillRef idx="3">
+            <a:schemeClr val="accent1"/>
+          </a:fillRef>
+          <a:effectRef idx="2">
+            <a:schemeClr val="accent1"/>
+          </a:effectRef>
+          <a:fontRef idx="minor">
+            <a:schemeClr val="lt1"/>
+          </a:fontRef>
+        </p:style>
+        <p:txBody>
+          <a:bodyPr rtlCol="0" anchor="ctr"/>
+          <a:lstStyle/>
+          <a:p>
+            <a:pPr algn="ctr"/>
+          </a:p>
+        </p:txBody>
+      </p:sp>
+      <p:sp>
+        <p:nvSpPr>
+          <p:cNvPr id="18" name="TextBox 17"/>
+          <p:cNvSpPr txBox="1"/>
+          <p:nvPr/>
+        </p:nvSpPr>
+        <p:spPr>
+          <a:xfrm>
+            <a:off x="6213599" y="2123999"/>
+            <a:ext cx="2448000" cy="360000"/>
+          </a:xfrm>
+          <a:prstGeom prst="rect">
+            <a:avLst/>
+          </a:prstGeom>
+          <a:noFill/>
+        </p:spPr>
+        <p:txBody>
+          <a:bodyPr wrap="square">
+            <a:spAutoFit/>
+          </a:bodyPr>
+          <a:lstStyle/>
+          <a:p>
+            <a:pPr>
+              <a:spcAft>
+                <a:spcPts val="400"/>
+              </a:spcAft>
+            </a:pPr>
+            <a:r>
+              <a:rPr sz="1500" b="1">
+                <a:solidFill>
+                  <a:srgbClr val="2F6DB5"/>
+                </a:solidFill>
+                <a:latin typeface="Arial"/>
+              </a:rPr>
+              <a:t>AI decision gate</a:t>
+            </a:r>
+          </a:p>
+        </p:txBody>
+      </p:sp>
+      <p:sp>
+        <p:nvSpPr>
+          <p:cNvPr id="19" name="TextBox 18"/>
+          <p:cNvSpPr txBox="1"/>
+          <p:nvPr/>
+        </p:nvSpPr>
+        <p:spPr>
+          <a:xfrm>
+            <a:off x="6213599" y="2519998"/>
+            <a:ext cx="2448000" cy="1512000"/>
+          </a:xfrm>
+          <a:prstGeom prst="rect">
+            <a:avLst/>
+          </a:prstGeom>
+          <a:noFill/>
+        </p:spPr>
+        <p:txBody>
+          <a:bodyPr wrap="square">
+            <a:spAutoFit/>
+          </a:bodyPr>
+          <a:lstStyle/>
+          <a:p>
+            <a:pPr>
+              <a:spcAft>
+                <a:spcPts val="400"/>
+              </a:spcAft>
+            </a:pPr>
+            <a:r>
+              <a:rPr sz="1300" b="0">
+                <a:solidFill>
+                  <a:srgbClr val="14213D"/>
+                </a:solidFill>
+                <a:latin typeface="Arial"/>
+              </a:rPr>
+              <a:t>Classifier trained on past manual-inspection results</a:t>
+            </a:r>
+          </a:p>
+          <a:p>
+            <a:pPr>
+              <a:spcAft>
+                <a:spcPts val="400"/>
+              </a:spcAft>
+            </a:pPr>
+            <a:r>
+              <a:rPr sz="1300" b="0">
+                <a:solidFill>
+                  <a:srgbClr val="14213D"/>
+                </a:solidFill>
+                <a:latin typeface="Arial"/>
+              </a:rPr>
+              <a:t>Release threshold: at most 1 % of defective boards released</a:t>
+            </a:r>
+          </a:p>
+        </p:txBody>
+      </p:sp>
+      <p:sp>
+        <p:nvSpPr>
+          <p:cNvPr id="20" name="TextBox 19"/>
+          <p:cNvSpPr txBox="1"/>
+          <p:nvPr/>
+        </p:nvSpPr>
+        <p:spPr>
+          <a:xfrm>
+            <a:off x="9111598" y="1710000"/>
+            <a:ext cx="2340000" cy="288000"/>
+          </a:xfrm>
+          <a:prstGeom prst="rect">
+            <a:avLst/>
+          </a:prstGeom>
+          <a:noFill/>
+        </p:spPr>
+        <p:txBody>
+          <a:bodyPr wrap="square">
+            <a:spAutoFit/>
+          </a:bodyPr>
+          <a:lstStyle/>
+          <a:p>
+            <a:pPr>
+              <a:spcAft>
+                <a:spcPts val="400"/>
+              </a:spcAft>
+            </a:pPr>
+            <a:r>
+              <a:rPr sz="1200" b="1">
+                <a:solidFill>
+                  <a:srgbClr val="2F6DB5"/>
+                </a:solidFill>
+                <a:latin typeface="Arial"/>
+              </a:rPr>
+              <a:t>OUTPUT</a:t>
+            </a:r>
+          </a:p>
+        </p:txBody>
+      </p:sp>
+      <p:sp>
+        <p:nvSpPr>
+          <p:cNvPr id="21" name="Right Arrow 20"/>
+          <p:cNvSpPr/>
+          <p:nvPr/>
+        </p:nvSpPr>
+        <p:spPr>
+          <a:xfrm>
+            <a:off x="8787599" y="2357999"/>
+            <a:ext cx="270000" cy="288000"/>
+          </a:xfrm>
+          <a:prstGeom prst="rightArrow">
+            <a:avLst/>
+          </a:prstGeom>
+          <a:solidFill>
+            <a:srgbClr val="2F6DB5"/>
+          </a:solidFill>
+          <a:ln>
+            <a:noFill/>
+          </a:ln>
+        </p:spPr>
+        <p:style>
+          <a:lnRef idx="1">
+            <a:schemeClr val="accent1"/>
+          </a:lnRef>
+          <a:fillRef idx="3">
+            <a:schemeClr val="accent1"/>
+          </a:fillRef>
+          <a:effectRef idx="2">
+            <a:schemeClr val="accent1"/>
+          </a:effectRef>
+          <a:fontRef idx="minor">
+            <a:schemeClr val="lt1"/>
+          </a:fontRef>
+        </p:style>
+        <p:txBody>
+          <a:bodyPr rtlCol="0" anchor="ctr"/>
+          <a:lstStyle/>
+          <a:p>
+            <a:pPr algn="ctr"/>
+          </a:p>
+        </p:txBody>
+      </p:sp>
+      <p:sp>
+        <p:nvSpPr>
+          <p:cNvPr id="22" name="Right Arrow 21"/>
+          <p:cNvSpPr/>
+          <p:nvPr/>
+        </p:nvSpPr>
+        <p:spPr>
+          <a:xfrm>
+            <a:off x="8787599" y="3473999"/>
+            <a:ext cx="270000" cy="288000"/>
+          </a:xfrm>
+          <a:prstGeom prst="rightArrow">
+            <a:avLst/>
+          </a:prstGeom>
+          <a:solidFill>
+            <a:srgbClr val="2F6DB5"/>
+          </a:solidFill>
+          <a:ln>
+            <a:noFill/>
+          </a:ln>
+        </p:spPr>
+        <p:style>
+          <a:lnRef idx="1">
+            <a:schemeClr val="accent1"/>
+          </a:lnRef>
+          <a:fillRef idx="3">
+            <a:schemeClr val="accent1"/>
+          </a:fillRef>
+          <a:effectRef idx="2">
+            <a:schemeClr val="accent1"/>
+          </a:effectRef>
+          <a:fontRef idx="minor">
+            <a:schemeClr val="lt1"/>
+          </a:fontRef>
+        </p:style>
+        <p:txBody>
+          <a:bodyPr rtlCol="0" anchor="ctr"/>
+          <a:lstStyle/>
+          <a:p>
+            <a:pPr algn="ctr"/>
+          </a:p>
+        </p:txBody>
+      </p:sp>
+      <p:sp>
+        <p:nvSpPr>
+          <p:cNvPr id="23" name="Rounded Rectangle 22"/>
+          <p:cNvSpPr/>
+          <p:nvPr/>
+        </p:nvSpPr>
+        <p:spPr>
+          <a:xfrm>
+            <a:off x="9111598" y="2015999"/>
+            <a:ext cx="2610001" cy="972000"/>
+          </a:xfrm>
+          <a:prstGeom prst="roundRect">
+            <a:avLst>
+              <a:gd name="adj" fmla="val 6000"/>
+            </a:avLst>
+          </a:prstGeom>
+          <a:solidFill>
+            <a:srgbClr val="E3F2E8"/>
           </a:solidFill>
           <a:ln>
             <a:noFill/>
@@ -9363,14 +9974,14 @@
       </p:sp>
       <p:sp>
         <p:nvSpPr>
-          <p:cNvPr id="12" name="TextBox 11"/>
-          <p:cNvSpPr txBox="1"/>
-          <p:nvPr/>
-        </p:nvSpPr>
-        <p:spPr>
-          <a:xfrm>
-            <a:off x="4683599" y="4553999"/>
-            <a:ext cx="3168000" cy="360000"/>
+          <p:cNvPr id="24" name="TextBox 23"/>
+          <p:cNvSpPr txBox="1"/>
+          <p:nvPr/>
+        </p:nvSpPr>
+        <p:spPr>
+          <a:xfrm>
+            <a:off x="9255598" y="2087999"/>
+            <a:ext cx="2160000" cy="360000"/>
           </a:xfrm>
           <a:prstGeom prst="rect">
             <a:avLst/>
@@ -9391,25 +10002,25 @@
             <a:r>
               <a:rPr sz="1500" b="1">
                 <a:solidFill>
-                  <a:srgbClr val="2F6DB5"/>
-                </a:solidFill>
-                <a:latin typeface="Arial"/>
-              </a:rPr>
-              <a:t>System</a:t>
-            </a:r>
-          </a:p>
-        </p:txBody>
-      </p:sp>
-      <p:sp>
-        <p:nvSpPr>
-          <p:cNvPr id="13" name="TextBox 12"/>
-          <p:cNvSpPr txBox="1"/>
-          <p:nvPr/>
-        </p:nvSpPr>
-        <p:spPr>
-          <a:xfrm>
-            <a:off x="4683599" y="4878000"/>
-            <a:ext cx="3168000" cy="648000"/>
+                  <a:srgbClr val="1D6B3A"/>
+                </a:solidFill>
+                <a:latin typeface="Arial"/>
+              </a:rPr>
+              <a:t>Release</a:t>
+            </a:r>
+          </a:p>
+        </p:txBody>
+      </p:sp>
+      <p:sp>
+        <p:nvSpPr>
+          <p:cNvPr id="25" name="TextBox 24"/>
+          <p:cNvSpPr txBox="1"/>
+          <p:nvPr/>
+        </p:nvSpPr>
+        <p:spPr>
+          <a:xfrm>
+            <a:off x="9255598" y="2429998"/>
+            <a:ext cx="2268000" cy="503999"/>
           </a:xfrm>
           <a:prstGeom prst="rect">
             <a:avLst/>
@@ -9434,21 +10045,145 @@
                 </a:solidFill>
                 <a:latin typeface="Arial"/>
               </a:rPr>
-              <a:t>Classifier trained on past manual-inspection results + release threshold (≤ 1 % defective boards released)</a:t>
-            </a:r>
-          </a:p>
-        </p:txBody>
-      </p:sp>
-      <p:sp>
-        <p:nvSpPr>
-          <p:cNvPr id="14" name="Rounded Rectangle 13"/>
+              <a:t>likely false call → next step</a:t>
+            </a:r>
+          </a:p>
+        </p:txBody>
+      </p:sp>
+      <p:sp>
+        <p:nvSpPr>
+          <p:cNvPr id="26" name="Rounded Rectangle 25"/>
           <p:cNvSpPr/>
           <p:nvPr/>
         </p:nvSpPr>
         <p:spPr>
           <a:xfrm>
-            <a:off x="8193599" y="4428000"/>
-            <a:ext cx="3528000" cy="1188000"/>
+            <a:off x="9111598" y="3131999"/>
+            <a:ext cx="2610001" cy="972000"/>
+          </a:xfrm>
+          <a:prstGeom prst="roundRect">
+            <a:avLst>
+              <a:gd name="adj" fmla="val 6000"/>
+            </a:avLst>
+          </a:prstGeom>
+          <a:solidFill>
+            <a:srgbClr val="FBE5E5"/>
+          </a:solidFill>
+          <a:ln>
+            <a:noFill/>
+          </a:ln>
+          <a:effectLst/>
+        </p:spPr>
+        <p:style>
+          <a:lnRef idx="1">
+            <a:schemeClr val="accent1"/>
+          </a:lnRef>
+          <a:fillRef idx="3">
+            <a:schemeClr val="accent1"/>
+          </a:fillRef>
+          <a:effectRef idx="2">
+            <a:schemeClr val="accent1"/>
+          </a:effectRef>
+          <a:fontRef idx="minor">
+            <a:schemeClr val="lt1"/>
+          </a:fontRef>
+        </p:style>
+        <p:txBody>
+          <a:bodyPr rtlCol="0" anchor="ctr"/>
+          <a:lstStyle/>
+          <a:p>
+            <a:pPr algn="ctr"/>
+          </a:p>
+        </p:txBody>
+      </p:sp>
+      <p:sp>
+        <p:nvSpPr>
+          <p:cNvPr id="27" name="TextBox 26"/>
+          <p:cNvSpPr txBox="1"/>
+          <p:nvPr/>
+        </p:nvSpPr>
+        <p:spPr>
+          <a:xfrm>
+            <a:off x="9255598" y="3203999"/>
+            <a:ext cx="2268000" cy="360000"/>
+          </a:xfrm>
+          <a:prstGeom prst="rect">
+            <a:avLst/>
+          </a:prstGeom>
+          <a:noFill/>
+        </p:spPr>
+        <p:txBody>
+          <a:bodyPr wrap="square">
+            <a:spAutoFit/>
+          </a:bodyPr>
+          <a:lstStyle/>
+          <a:p>
+            <a:pPr>
+              <a:spcAft>
+                <a:spcPts val="400"/>
+              </a:spcAft>
+            </a:pPr>
+            <a:r>
+              <a:rPr sz="1500" b="1">
+                <a:solidFill>
+                  <a:srgbClr val="A12A2A"/>
+                </a:solidFill>
+                <a:latin typeface="Arial"/>
+              </a:rPr>
+              <a:t>Manual inspection</a:t>
+            </a:r>
+          </a:p>
+        </p:txBody>
+      </p:sp>
+      <p:sp>
+        <p:nvSpPr>
+          <p:cNvPr id="28" name="TextBox 27"/>
+          <p:cNvSpPr txBox="1"/>
+          <p:nvPr/>
+        </p:nvSpPr>
+        <p:spPr>
+          <a:xfrm>
+            <a:off x="9255598" y="3545999"/>
+            <a:ext cx="2268000" cy="503999"/>
+          </a:xfrm>
+          <a:prstGeom prst="rect">
+            <a:avLst/>
+          </a:prstGeom>
+          <a:noFill/>
+        </p:spPr>
+        <p:txBody>
+          <a:bodyPr wrap="square">
+            <a:spAutoFit/>
+          </a:bodyPr>
+          <a:lstStyle/>
+          <a:p>
+            <a:pPr>
+              <a:spcAft>
+                <a:spcPts val="400"/>
+              </a:spcAft>
+            </a:pPr>
+            <a:r>
+              <a:rPr sz="1200" b="0">
+                <a:solidFill>
+                  <a:srgbClr val="14213D"/>
+                </a:solidFill>
+                <a:latin typeface="Arial"/>
+              </a:rPr>
+              <a:t>possible defect → operator checks</a:t>
+            </a:r>
+          </a:p>
+        </p:txBody>
+      </p:sp>
+      <p:sp>
+        <p:nvSpPr>
+          <p:cNvPr id="29" name="Rounded Rectangle 28"/>
+          <p:cNvSpPr/>
+          <p:nvPr/>
+        </p:nvSpPr>
+        <p:spPr>
+          <a:xfrm>
+            <a:off x="813599" y="4392000"/>
+            <a:ext cx="5364000" cy="1044000"/>
           </a:xfrm>
           <a:prstGeom prst="roundRect">
             <a:avLst>
@@ -9487,14 +10222,14 @@
       </p:sp>
       <p:sp>
         <p:nvSpPr>
-          <p:cNvPr id="15" name="TextBox 14"/>
-          <p:cNvSpPr txBox="1"/>
-          <p:nvPr/>
-        </p:nvSpPr>
-        <p:spPr>
-          <a:xfrm>
-            <a:off x="8373599" y="4553999"/>
-            <a:ext cx="3168000" cy="360000"/>
+          <p:cNvPr id="30" name="TextBox 29"/>
+          <p:cNvSpPr txBox="1"/>
+          <p:nvPr/>
+        </p:nvSpPr>
+        <p:spPr>
+          <a:xfrm>
+            <a:off x="993599" y="4500000"/>
+            <a:ext cx="5040000" cy="324000"/>
           </a:xfrm>
           <a:prstGeom prst="rect">
             <a:avLst/>
@@ -9513,27 +10248,27 @@
               </a:spcAft>
             </a:pPr>
             <a:r>
-              <a:rPr sz="1500" b="1">
-                <a:solidFill>
-                  <a:srgbClr val="2F6DB5"/>
-                </a:solidFill>
-                <a:latin typeface="Arial"/>
-              </a:rPr>
-              <a:t>Output → impact</a:t>
-            </a:r>
-          </a:p>
-        </p:txBody>
-      </p:sp>
-      <p:sp>
-        <p:nvSpPr>
-          <p:cNvPr id="16" name="TextBox 15"/>
-          <p:cNvSpPr txBox="1"/>
-          <p:nvPr/>
-        </p:nvSpPr>
-        <p:spPr>
-          <a:xfrm>
-            <a:off x="8373599" y="4878000"/>
-            <a:ext cx="3168000" cy="648000"/>
+              <a:rPr sz="1400" b="1">
+                <a:solidFill>
+                  <a:srgbClr val="555F6D"/>
+                </a:solidFill>
+                <a:latin typeface="Arial"/>
+              </a:rPr>
+              <a:t>Today</a:t>
+            </a:r>
+          </a:p>
+        </p:txBody>
+      </p:sp>
+      <p:sp>
+        <p:nvSpPr>
+          <p:cNvPr id="31" name="TextBox 30"/>
+          <p:cNvSpPr txBox="1"/>
+          <p:nvPr/>
+        </p:nvSpPr>
+        <p:spPr>
+          <a:xfrm>
+            <a:off x="993599" y="4788000"/>
+            <a:ext cx="5040000" cy="612000"/>
           </a:xfrm>
           <a:prstGeom prst="rect">
             <a:avLst/>
@@ -9552,13 +10287,137 @@
               </a:spcAft>
             </a:pPr>
             <a:r>
-              <a:rPr sz="1200" b="0">
+              <a:rPr sz="1400" b="0">
                 <a:solidFill>
                   <a:srgbClr val="14213D"/>
                 </a:solidFill>
                 <a:latin typeface="Arial"/>
               </a:rPr>
-              <a:t>Release or send to manual inspection → less manual work, same quality</a:t>
+              <a:t>Every flagged board is checked by hand, and 98 % of them are fine.</a:t>
+            </a:r>
+          </a:p>
+        </p:txBody>
+      </p:sp>
+      <p:sp>
+        <p:nvSpPr>
+          <p:cNvPr id="32" name="Rounded Rectangle 31"/>
+          <p:cNvSpPr/>
+          <p:nvPr/>
+        </p:nvSpPr>
+        <p:spPr>
+          <a:xfrm>
+            <a:off x="6357599" y="4392000"/>
+            <a:ext cx="5364000" cy="1044000"/>
+          </a:xfrm>
+          <a:prstGeom prst="roundRect">
+            <a:avLst>
+              <a:gd name="adj" fmla="val 6000"/>
+            </a:avLst>
+          </a:prstGeom>
+          <a:solidFill>
+            <a:srgbClr val="14213D"/>
+          </a:solidFill>
+          <a:ln>
+            <a:noFill/>
+          </a:ln>
+          <a:effectLst/>
+        </p:spPr>
+        <p:style>
+          <a:lnRef idx="1">
+            <a:schemeClr val="accent1"/>
+          </a:lnRef>
+          <a:fillRef idx="3">
+            <a:schemeClr val="accent1"/>
+          </a:fillRef>
+          <a:effectRef idx="2">
+            <a:schemeClr val="accent1"/>
+          </a:effectRef>
+          <a:fontRef idx="minor">
+            <a:schemeClr val="lt1"/>
+          </a:fontRef>
+        </p:style>
+        <p:txBody>
+          <a:bodyPr rtlCol="0" anchor="ctr"/>
+          <a:lstStyle/>
+          <a:p>
+            <a:pPr algn="ctr"/>
+          </a:p>
+        </p:txBody>
+      </p:sp>
+      <p:sp>
+        <p:nvSpPr>
+          <p:cNvPr id="33" name="TextBox 32"/>
+          <p:cNvSpPr txBox="1"/>
+          <p:nvPr/>
+        </p:nvSpPr>
+        <p:spPr>
+          <a:xfrm>
+            <a:off x="6537599" y="4500000"/>
+            <a:ext cx="5040000" cy="324000"/>
+          </a:xfrm>
+          <a:prstGeom prst="rect">
+            <a:avLst/>
+          </a:prstGeom>
+          <a:noFill/>
+        </p:spPr>
+        <p:txBody>
+          <a:bodyPr wrap="square">
+            <a:spAutoFit/>
+          </a:bodyPr>
+          <a:lstStyle/>
+          <a:p>
+            <a:pPr>
+              <a:spcAft>
+                <a:spcPts val="400"/>
+              </a:spcAft>
+            </a:pPr>
+            <a:r>
+              <a:rPr sz="1400" b="1">
+                <a:solidFill>
+                  <a:srgbClr val="B8C4D6"/>
+                </a:solidFill>
+                <a:latin typeface="Arial"/>
+              </a:rPr>
+              <a:t>With the gate (goal)</a:t>
+            </a:r>
+          </a:p>
+        </p:txBody>
+      </p:sp>
+      <p:sp>
+        <p:nvSpPr>
+          <p:cNvPr id="34" name="TextBox 33"/>
+          <p:cNvSpPr txBox="1"/>
+          <p:nvPr/>
+        </p:nvSpPr>
+        <p:spPr>
+          <a:xfrm>
+            <a:off x="6537599" y="4788000"/>
+            <a:ext cx="5040000" cy="612000"/>
+          </a:xfrm>
+          <a:prstGeom prst="rect">
+            <a:avLst/>
+          </a:prstGeom>
+          <a:noFill/>
+        </p:spPr>
+        <p:txBody>
+          <a:bodyPr wrap="square">
+            <a:spAutoFit/>
+          </a:bodyPr>
+          <a:lstStyle/>
+          <a:p>
+            <a:pPr>
+              <a:spcAft>
+                <a:spcPts val="400"/>
+              </a:spcAft>
+            </a:pPr>
+            <a:r>
+              <a:rPr sz="1400" b="0">
+                <a:solidFill>
+                  <a:srgbClr val="FFFFFF"/>
+                </a:solidFill>
+                <a:latin typeface="Arial"/>
+              </a:rPr>
+              <a:t>Fewer manual checks, same quality: at most 1 % of defective boards released.</a:t>
             </a:r>
           </a:p>
         </p:txBody>

</xml_diff>

<commit_message>
Concrete deliverables; realistic future work
</commit_message>
<xml_diff>
--- a/docs/slides_revised_topic.pptx
+++ b/docs/slides_revised_topic.pptx
@@ -9724,7 +9724,7 @@
                 </a:solidFill>
                 <a:latin typeface="Arial"/>
               </a:rPr>
-              <a:t>What we will hand in</a:t>
+              <a:t>What we hand in, concretely: a software prototype</a:t>
             </a:r>
           </a:p>
         </p:txBody>
@@ -9839,8 +9839,132 @@
         </p:nvSpPr>
         <p:spPr>
           <a:xfrm>
-            <a:off x="813599" y="1800000"/>
-            <a:ext cx="5364000" cy="1655999"/>
+            <a:off x="813599" y="1764000"/>
+            <a:ext cx="5256000" cy="1655999"/>
+          </a:xfrm>
+          <a:prstGeom prst="roundRect">
+            <a:avLst>
+              <a:gd name="adj" fmla="val 6000"/>
+            </a:avLst>
+          </a:prstGeom>
+          <a:solidFill>
+            <a:srgbClr val="DCE7F5"/>
+          </a:solidFill>
+          <a:ln>
+            <a:noFill/>
+          </a:ln>
+          <a:effectLst/>
+        </p:spPr>
+        <p:style>
+          <a:lnRef idx="1">
+            <a:schemeClr val="accent1"/>
+          </a:lnRef>
+          <a:fillRef idx="3">
+            <a:schemeClr val="accent1"/>
+          </a:fillRef>
+          <a:effectRef idx="2">
+            <a:schemeClr val="accent1"/>
+          </a:effectRef>
+          <a:fontRef idx="minor">
+            <a:schemeClr val="lt1"/>
+          </a:fontRef>
+        </p:style>
+        <p:txBody>
+          <a:bodyPr rtlCol="0" anchor="ctr"/>
+          <a:lstStyle/>
+          <a:p>
+            <a:pPr algn="ctr"/>
+          </a:p>
+        </p:txBody>
+      </p:sp>
+      <p:sp>
+        <p:nvSpPr>
+          <p:cNvPr id="8" name="TextBox 7"/>
+          <p:cNvSpPr txBox="1"/>
+          <p:nvPr/>
+        </p:nvSpPr>
+        <p:spPr>
+          <a:xfrm>
+            <a:off x="993599" y="1889999"/>
+            <a:ext cx="4896000" cy="360000"/>
+          </a:xfrm>
+          <a:prstGeom prst="rect">
+            <a:avLst/>
+          </a:prstGeom>
+          <a:noFill/>
+        </p:spPr>
+        <p:txBody>
+          <a:bodyPr wrap="square">
+            <a:spAutoFit/>
+          </a:bodyPr>
+          <a:lstStyle/>
+          <a:p>
+            <a:pPr>
+              <a:spcAft>
+                <a:spcPts val="400"/>
+              </a:spcAft>
+            </a:pPr>
+            <a:r>
+              <a:rPr sz="1500" b="1">
+                <a:solidFill>
+                  <a:srgbClr val="2F6DB5"/>
+                </a:solidFill>
+                <a:latin typeface="Arial"/>
+              </a:rPr>
+              <a:t>1 · Software: the AI decision gate</a:t>
+            </a:r>
+          </a:p>
+        </p:txBody>
+      </p:sp>
+      <p:sp>
+        <p:nvSpPr>
+          <p:cNvPr id="9" name="TextBox 8"/>
+          <p:cNvSpPr txBox="1"/>
+          <p:nvPr/>
+        </p:nvSpPr>
+        <p:spPr>
+          <a:xfrm>
+            <a:off x="993599" y="2214000"/>
+            <a:ext cx="4896000" cy="1115999"/>
+          </a:xfrm>
+          <a:prstGeom prst="rect">
+            <a:avLst/>
+          </a:prstGeom>
+          <a:noFill/>
+        </p:spPr>
+        <p:txBody>
+          <a:bodyPr wrap="square">
+            <a:spAutoFit/>
+          </a:bodyPr>
+          <a:lstStyle/>
+          <a:p>
+            <a:pPr>
+              <a:spcAft>
+                <a:spcPts val="400"/>
+              </a:spcAft>
+            </a:pPr>
+            <a:r>
+              <a:rPr sz="1200" b="0">
+                <a:solidFill>
+                  <a:srgbClr val="14213D"/>
+                </a:solidFill>
+                <a:latin typeface="Arial"/>
+              </a:rPr>
+              <a:t>A Python package with a command-line tool. Train it on past inspection records; give it the AOI data of one board; it answers RELEASE or INSPECT, with a score and the main reasons.</a:t>
+            </a:r>
+          </a:p>
+        </p:txBody>
+      </p:sp>
+      <p:sp>
+        <p:nvSpPr>
+          <p:cNvPr id="10" name="Rounded Rectangle 9"/>
+          <p:cNvSpPr/>
+          <p:nvPr/>
+        </p:nvSpPr>
+        <p:spPr>
+          <a:xfrm>
+            <a:off x="813599" y="3564000"/>
+            <a:ext cx="5256000" cy="1655999"/>
           </a:xfrm>
           <a:prstGeom prst="roundRect">
             <a:avLst>
@@ -9879,14 +10003,14 @@
       </p:sp>
       <p:sp>
         <p:nvSpPr>
-          <p:cNvPr id="8" name="TextBox 7"/>
-          <p:cNvSpPr txBox="1"/>
-          <p:nvPr/>
-        </p:nvSpPr>
-        <p:spPr>
-          <a:xfrm>
-            <a:off x="993599" y="1925999"/>
-            <a:ext cx="5004000" cy="360000"/>
+          <p:cNvPr id="11" name="TextBox 10"/>
+          <p:cNvSpPr txBox="1"/>
+          <p:nvPr/>
+        </p:nvSpPr>
+        <p:spPr>
+          <a:xfrm>
+            <a:off x="993599" y="3689999"/>
+            <a:ext cx="4896000" cy="360000"/>
           </a:xfrm>
           <a:prstGeom prst="rect">
             <a:avLst/>
@@ -9911,60 +10035,257 @@
                 </a:solidFill>
                 <a:latin typeface="Arial"/>
               </a:rPr>
-              <a:t>AI decision gate</a:t>
-            </a:r>
-          </a:p>
-        </p:txBody>
-      </p:sp>
-      <p:sp>
-        <p:nvSpPr>
-          <p:cNvPr id="9" name="TextBox 8"/>
-          <p:cNvSpPr txBox="1"/>
-          <p:nvPr/>
-        </p:nvSpPr>
-        <p:spPr>
-          <a:xfrm>
-            <a:off x="993599" y="2250000"/>
-            <a:ext cx="5004000" cy="1115999"/>
-          </a:xfrm>
-          <a:prstGeom prst="rect">
-            <a:avLst/>
-          </a:prstGeom>
-          <a:noFill/>
-        </p:spPr>
-        <p:txBody>
-          <a:bodyPr wrap="square">
-            <a:spAutoFit/>
-          </a:bodyPr>
-          <a:lstStyle/>
-          <a:p>
-            <a:pPr>
-              <a:spcAft>
-                <a:spcPts val="400"/>
-              </a:spcAft>
-            </a:pPr>
-            <a:r>
-              <a:rPr sz="1400" b="0">
+              <a:t>2 · Replay dashboard (demo)</a:t>
+            </a:r>
+          </a:p>
+        </p:txBody>
+      </p:sp>
+      <p:sp>
+        <p:nvSpPr>
+          <p:cNvPr id="12" name="TextBox 11"/>
+          <p:cNvSpPr txBox="1"/>
+          <p:nvPr/>
+        </p:nvSpPr>
+        <p:spPr>
+          <a:xfrm>
+            <a:off x="993599" y="4014000"/>
+            <a:ext cx="4896000" cy="1115999"/>
+          </a:xfrm>
+          <a:prstGeom prst="rect">
+            <a:avLst/>
+          </a:prstGeom>
+          <a:noFill/>
+        </p:spPr>
+        <p:txBody>
+          <a:bodyPr wrap="square">
+            <a:spAutoFit/>
+          </a:bodyPr>
+          <a:lstStyle/>
+          <a:p>
+            <a:pPr>
+              <a:spcAft>
+                <a:spcPts val="400"/>
+              </a:spcAft>
+            </a:pPr>
+            <a:r>
+              <a:rPr sz="1200" b="0">
                 <a:solidFill>
                   <a:srgbClr val="14213D"/>
                 </a:solidFill>
                 <a:latin typeface="Arial"/>
               </a:rPr>
-              <a:t>Working, tested code that decides release or manual inspection per board.</a:t>
-            </a:r>
-          </a:p>
-        </p:txBody>
-      </p:sp>
-      <p:sp>
-        <p:nvSpPr>
-          <p:cNvPr id="10" name="Rounded Rectangle 9"/>
+              <a:t>A small web app: pick a day of the Siemens line and see each board’s decision, manual checks saved, defects released and drift alarms.</a:t>
+            </a:r>
+          </a:p>
+        </p:txBody>
+      </p:sp>
+      <p:sp>
+        <p:nvSpPr>
+          <p:cNvPr id="13" name="Rounded Rectangle 12"/>
           <p:cNvSpPr/>
           <p:nvPr/>
         </p:nvSpPr>
         <p:spPr>
           <a:xfrm>
-            <a:off x="6357599" y="1800000"/>
-            <a:ext cx="5364000" cy="1655999"/>
+            <a:off x="6429599" y="1764000"/>
+            <a:ext cx="5292000" cy="2015999"/>
+          </a:xfrm>
+          <a:prstGeom prst="roundRect">
+            <a:avLst>
+              <a:gd name="adj" fmla="val 6000"/>
+            </a:avLst>
+          </a:prstGeom>
+          <a:solidFill>
+            <a:srgbClr val="14213D"/>
+          </a:solidFill>
+          <a:ln>
+            <a:noFill/>
+          </a:ln>
+          <a:effectLst/>
+        </p:spPr>
+        <p:style>
+          <a:lnRef idx="1">
+            <a:schemeClr val="accent1"/>
+          </a:lnRef>
+          <a:fillRef idx="3">
+            <a:schemeClr val="accent1"/>
+          </a:fillRef>
+          <a:effectRef idx="2">
+            <a:schemeClr val="accent1"/>
+          </a:effectRef>
+          <a:fontRef idx="minor">
+            <a:schemeClr val="lt1"/>
+          </a:fontRef>
+        </p:style>
+        <p:txBody>
+          <a:bodyPr rtlCol="0" anchor="ctr"/>
+          <a:lstStyle/>
+          <a:p>
+            <a:pPr algn="ctr"/>
+          </a:p>
+        </p:txBody>
+      </p:sp>
+      <p:sp>
+        <p:nvSpPr>
+          <p:cNvPr id="14" name="TextBox 13"/>
+          <p:cNvSpPr txBox="1"/>
+          <p:nvPr/>
+        </p:nvSpPr>
+        <p:spPr>
+          <a:xfrm>
+            <a:off x="6573599" y="1835999"/>
+            <a:ext cx="5040000" cy="1908000"/>
+          </a:xfrm>
+          <a:prstGeom prst="rect">
+            <a:avLst/>
+          </a:prstGeom>
+          <a:noFill/>
+        </p:spPr>
+        <p:txBody>
+          <a:bodyPr wrap="square">
+            <a:spAutoFit/>
+          </a:bodyPr>
+          <a:lstStyle/>
+          <a:p>
+            <a:pPr>
+              <a:spcAft>
+                <a:spcPts val="400"/>
+              </a:spcAft>
+            </a:pPr>
+            <a:r>
+              <a:rPr sz="1100" b="0">
+                <a:solidFill>
+                  <a:srgbClr val="FFFFFF"/>
+                </a:solidFill>
+                <a:latin typeface="Arial"/>
+              </a:rPr>
+              <a:t># planned command-line interface (day 87 = real replay result)</a:t>
+            </a:r>
+          </a:p>
+          <a:p>
+            <a:pPr>
+              <a:spcAft>
+                <a:spcPts val="400"/>
+              </a:spcAft>
+            </a:pPr>
+            <a:r>
+              <a:rPr sz="1100" b="0">
+                <a:solidFill>
+                  <a:srgbClr val="FFFFFF"/>
+                </a:solidFill>
+                <a:latin typeface="Arial"/>
+              </a:rPr>
+              <a:t> </a:t>
+            </a:r>
+          </a:p>
+          <a:p>
+            <a:pPr>
+              <a:spcAft>
+                <a:spcPts val="400"/>
+              </a:spcAft>
+            </a:pPr>
+            <a:r>
+              <a:rPr sz="1100" b="0">
+                <a:solidFill>
+                  <a:srgbClr val="FFFFFF"/>
+                </a:solidFill>
+                <a:latin typeface="Arial"/>
+              </a:rPr>
+              <a:t>$ aoi-gate train   --data history.csv</a:t>
+            </a:r>
+          </a:p>
+          <a:p>
+            <a:pPr>
+              <a:spcAft>
+                <a:spcPts val="400"/>
+              </a:spcAft>
+            </a:pPr>
+            <a:r>
+              <a:rPr sz="1100" b="0">
+                <a:solidFill>
+                  <a:srgbClr val="FFFFFF"/>
+                </a:solidFill>
+                <a:latin typeface="Arial"/>
+              </a:rPr>
+              <a:t>  model saved, threshold set (≤ 1 % defects released)</a:t>
+            </a:r>
+          </a:p>
+          <a:p>
+            <a:pPr>
+              <a:spcAft>
+                <a:spcPts val="400"/>
+              </a:spcAft>
+            </a:pPr>
+            <a:r>
+              <a:rPr sz="1100" b="0">
+                <a:solidFill>
+                  <a:srgbClr val="FFFFFF"/>
+                </a:solidFill>
+                <a:latin typeface="Arial"/>
+              </a:rPr>
+              <a:t>$ aoi-gate decide  --board board_10466.csv</a:t>
+            </a:r>
+          </a:p>
+          <a:p>
+            <a:pPr>
+              <a:spcAft>
+                <a:spcPts val="400"/>
+              </a:spcAft>
+            </a:pPr>
+            <a:r>
+              <a:rPr sz="1100" b="0">
+                <a:solidFill>
+                  <a:srgbClr val="FFFFFF"/>
+                </a:solidFill>
+                <a:latin typeface="Arial"/>
+              </a:rPr>
+              <a:t>  RELEASE   (score below threshold: likely false call)</a:t>
+            </a:r>
+          </a:p>
+          <a:p>
+            <a:pPr>
+              <a:spcAft>
+                <a:spcPts val="400"/>
+              </a:spcAft>
+            </a:pPr>
+            <a:r>
+              <a:rPr sz="1100" b="0">
+                <a:solidFill>
+                  <a:srgbClr val="FFFFFF"/>
+                </a:solidFill>
+                <a:latin typeface="Arial"/>
+              </a:rPr>
+              <a:t>$ aoi-gate replay  --policy weekly</a:t>
+            </a:r>
+          </a:p>
+          <a:p>
+            <a:pPr>
+              <a:spcAft>
+                <a:spcPts val="400"/>
+              </a:spcAft>
+            </a:pPr>
+            <a:r>
+              <a:rPr sz="1100" b="0">
+                <a:solidFill>
+                  <a:srgbClr val="FFFFFF"/>
+                </a:solidFill>
+                <a:latin typeface="Arial"/>
+              </a:rPr>
+              <a:t>  day 87: 612 boards, 183 checks saved, 0 defects released</a:t>
+            </a:r>
+          </a:p>
+        </p:txBody>
+      </p:sp>
+      <p:sp>
+        <p:nvSpPr>
+          <p:cNvPr id="15" name="Rounded Rectangle 14"/>
+          <p:cNvSpPr/>
+          <p:nvPr/>
+        </p:nvSpPr>
+        <p:spPr>
+          <a:xfrm>
+            <a:off x="6429599" y="3924000"/>
+            <a:ext cx="5292000" cy="1296000"/>
           </a:xfrm>
           <a:prstGeom prst="roundRect">
             <a:avLst>
@@ -10003,14 +10324,14 @@
       </p:sp>
       <p:sp>
         <p:nvSpPr>
-          <p:cNvPr id="11" name="TextBox 10"/>
-          <p:cNvSpPr txBox="1"/>
-          <p:nvPr/>
-        </p:nvSpPr>
-        <p:spPr>
-          <a:xfrm>
-            <a:off x="6537599" y="1925999"/>
-            <a:ext cx="5004000" cy="360000"/>
+          <p:cNvPr id="16" name="TextBox 15"/>
+          <p:cNvSpPr txBox="1"/>
+          <p:nvPr/>
+        </p:nvSpPr>
+        <p:spPr>
+          <a:xfrm>
+            <a:off x="6609599" y="4049999"/>
+            <a:ext cx="4932000" cy="360000"/>
           </a:xfrm>
           <a:prstGeom prst="rect">
             <a:avLst/>
@@ -10035,255 +10356,46 @@
                 </a:solidFill>
                 <a:latin typeface="Arial"/>
               </a:rPr>
-              <a:t>Replay simulation</a:t>
-            </a:r>
-          </a:p>
-        </p:txBody>
-      </p:sp>
-      <p:sp>
-        <p:nvSpPr>
-          <p:cNvPr id="12" name="TextBox 11"/>
-          <p:cNvSpPr txBox="1"/>
-          <p:nvPr/>
-        </p:nvSpPr>
-        <p:spPr>
-          <a:xfrm>
-            <a:off x="6537599" y="2250000"/>
-            <a:ext cx="5004000" cy="1115999"/>
-          </a:xfrm>
-          <a:prstGeom prst="rect">
-            <a:avLst/>
-          </a:prstGeom>
-          <a:noFill/>
-        </p:spPr>
-        <p:txBody>
-          <a:bodyPr wrap="square">
-            <a:spAutoFit/>
-          </a:bodyPr>
-          <a:lstStyle/>
-          <a:p>
-            <a:pPr>
-              <a:spcAft>
-                <a:spcPts val="400"/>
-              </a:spcAft>
-            </a:pPr>
-            <a:r>
-              <a:rPr sz="1400" b="0">
+              <a:t>3 · Evidence and documents</a:t>
+            </a:r>
+          </a:p>
+        </p:txBody>
+      </p:sp>
+      <p:sp>
+        <p:nvSpPr>
+          <p:cNvPr id="17" name="TextBox 16"/>
+          <p:cNvSpPr txBox="1"/>
+          <p:nvPr/>
+        </p:nvSpPr>
+        <p:spPr>
+          <a:xfrm>
+            <a:off x="6609599" y="4374000"/>
+            <a:ext cx="4932000" cy="756000"/>
+          </a:xfrm>
+          <a:prstGeom prst="rect">
+            <a:avLst/>
+          </a:prstGeom>
+          <a:noFill/>
+        </p:spPr>
+        <p:txBody>
+          <a:bodyPr wrap="square">
+            <a:spAutoFit/>
+          </a:bodyPr>
+          <a:lstStyle/>
+          <a:p>
+            <a:pPr>
+              <a:spcAft>
+                <a:spcPts val="400"/>
+              </a:spcAft>
+            </a:pPr>
+            <a:r>
+              <a:rPr sz="1200" b="0">
                 <a:solidFill>
                   <a:srgbClr val="14213D"/>
                 </a:solidFill>
                 <a:latin typeface="Arial"/>
               </a:rPr>
-              <a:t>Day-by-day replay of the Siemens line with production KPIs per update policy.</a:t>
-            </a:r>
-          </a:p>
-        </p:txBody>
-      </p:sp>
-      <p:sp>
-        <p:nvSpPr>
-          <p:cNvPr id="13" name="Rounded Rectangle 12"/>
-          <p:cNvSpPr/>
-          <p:nvPr/>
-        </p:nvSpPr>
-        <p:spPr>
-          <a:xfrm>
-            <a:off x="813599" y="3635999"/>
-            <a:ext cx="5364000" cy="1655999"/>
-          </a:xfrm>
-          <a:prstGeom prst="roundRect">
-            <a:avLst>
-              <a:gd name="adj" fmla="val 6000"/>
-            </a:avLst>
-          </a:prstGeom>
-          <a:solidFill>
-            <a:srgbClr val="FFFFFF"/>
-          </a:solidFill>
-          <a:ln>
-            <a:noFill/>
-          </a:ln>
-          <a:effectLst/>
-        </p:spPr>
-        <p:style>
-          <a:lnRef idx="1">
-            <a:schemeClr val="accent1"/>
-          </a:lnRef>
-          <a:fillRef idx="3">
-            <a:schemeClr val="accent1"/>
-          </a:fillRef>
-          <a:effectRef idx="2">
-            <a:schemeClr val="accent1"/>
-          </a:effectRef>
-          <a:fontRef idx="minor">
-            <a:schemeClr val="lt1"/>
-          </a:fontRef>
-        </p:style>
-        <p:txBody>
-          <a:bodyPr rtlCol="0" anchor="ctr"/>
-          <a:lstStyle/>
-          <a:p>
-            <a:pPr algn="ctr"/>
-          </a:p>
-        </p:txBody>
-      </p:sp>
-      <p:sp>
-        <p:nvSpPr>
-          <p:cNvPr id="14" name="TextBox 13"/>
-          <p:cNvSpPr txBox="1"/>
-          <p:nvPr/>
-        </p:nvSpPr>
-        <p:spPr>
-          <a:xfrm>
-            <a:off x="993599" y="3761998"/>
-            <a:ext cx="5004000" cy="360000"/>
-          </a:xfrm>
-          <a:prstGeom prst="rect">
-            <a:avLst/>
-          </a:prstGeom>
-          <a:noFill/>
-        </p:spPr>
-        <p:txBody>
-          <a:bodyPr wrap="square">
-            <a:spAutoFit/>
-          </a:bodyPr>
-          <a:lstStyle/>
-          <a:p>
-            <a:pPr>
-              <a:spcAft>
-                <a:spcPts val="400"/>
-              </a:spcAft>
-            </a:pPr>
-            <a:r>
-              <a:rPr sz="1500" b="1">
-                <a:solidFill>
-                  <a:srgbClr val="2F6DB5"/>
-                </a:solidFill>
-                <a:latin typeface="Arial"/>
-              </a:rPr>
-              <a:t>Comparison</a:t>
-            </a:r>
-          </a:p>
-        </p:txBody>
-      </p:sp>
-      <p:sp>
-        <p:nvSpPr>
-          <p:cNvPr id="15" name="TextBox 14"/>
-          <p:cNvSpPr txBox="1"/>
-          <p:nvPr/>
-        </p:nvSpPr>
-        <p:spPr>
-          <a:xfrm>
-            <a:off x="993599" y="4085999"/>
-            <a:ext cx="5004000" cy="1115999"/>
-          </a:xfrm>
-          <a:prstGeom prst="rect">
-            <a:avLst/>
-          </a:prstGeom>
-          <a:noFill/>
-        </p:spPr>
-        <p:txBody>
-          <a:bodyPr wrap="square">
-            <a:spAutoFit/>
-          </a:bodyPr>
-          <a:lstStyle/>
-          <a:p>
-            <a:pPr>
-              <a:spcAft>
-                <a:spcPts val="400"/>
-              </a:spcAft>
-            </a:pPr>
-            <a:r>
-              <a:rPr sz="1400" b="0">
-                <a:solidFill>
-                  <a:srgbClr val="14213D"/>
-                </a:solidFill>
-                <a:latin typeface="Arial"/>
-              </a:rPr>
-              <a:t>Trees vs. neural network, and update policies, measured against our targets.</a:t>
-            </a:r>
-          </a:p>
-        </p:txBody>
-      </p:sp>
-      <p:sp>
-        <p:nvSpPr>
-          <p:cNvPr id="16" name="Rounded Rectangle 15"/>
-          <p:cNvSpPr/>
-          <p:nvPr/>
-        </p:nvSpPr>
-        <p:spPr>
-          <a:xfrm>
-            <a:off x="6357599" y="3635999"/>
-            <a:ext cx="5364000" cy="1655999"/>
-          </a:xfrm>
-          <a:prstGeom prst="roundRect">
-            <a:avLst>
-              <a:gd name="adj" fmla="val 6000"/>
-            </a:avLst>
-          </a:prstGeom>
-          <a:solidFill>
-            <a:srgbClr val="FFFFFF"/>
-          </a:solidFill>
-          <a:ln>
-            <a:noFill/>
-          </a:ln>
-          <a:effectLst/>
-        </p:spPr>
-        <p:style>
-          <a:lnRef idx="1">
-            <a:schemeClr val="accent1"/>
-          </a:lnRef>
-          <a:fillRef idx="3">
-            <a:schemeClr val="accent1"/>
-          </a:fillRef>
-          <a:effectRef idx="2">
-            <a:schemeClr val="accent1"/>
-          </a:effectRef>
-          <a:fontRef idx="minor">
-            <a:schemeClr val="lt1"/>
-          </a:fontRef>
-        </p:style>
-        <p:txBody>
-          <a:bodyPr rtlCol="0" anchor="ctr"/>
-          <a:lstStyle/>
-          <a:p>
-            <a:pPr algn="ctr"/>
-          </a:p>
-        </p:txBody>
-      </p:sp>
-      <p:sp>
-        <p:nvSpPr>
-          <p:cNvPr id="17" name="TextBox 16"/>
-          <p:cNvSpPr txBox="1"/>
-          <p:nvPr/>
-        </p:nvSpPr>
-        <p:spPr>
-          <a:xfrm>
-            <a:off x="6537599" y="3761998"/>
-            <a:ext cx="5004000" cy="360000"/>
-          </a:xfrm>
-          <a:prstGeom prst="rect">
-            <a:avLst/>
-          </a:prstGeom>
-          <a:noFill/>
-        </p:spPr>
-        <p:txBody>
-          <a:bodyPr wrap="square">
-            <a:spAutoFit/>
-          </a:bodyPr>
-          <a:lstStyle/>
-          <a:p>
-            <a:pPr>
-              <a:spcAft>
-                <a:spcPts val="400"/>
-              </a:spcAft>
-            </a:pPr>
-            <a:r>
-              <a:rPr sz="1500" b="1">
-                <a:solidFill>
-                  <a:srgbClr val="2F6DB5"/>
-                </a:solidFill>
-                <a:latin typeface="Arial"/>
-              </a:rPr>
-              <a:t>Report and demo</a:t>
+              <a:t>Result files for every number · tests on every push · demo video · final report · public GitHub repository</a:t>
             </a:r>
           </a:p>
         </p:txBody>
@@ -10296,33 +10408,33 @@
         </p:nvSpPr>
         <p:spPr>
           <a:xfrm>
-            <a:off x="6537599" y="4085999"/>
-            <a:ext cx="5004000" cy="1115999"/>
-          </a:xfrm>
-          <a:prstGeom prst="rect">
-            <a:avLst/>
-          </a:prstGeom>
-          <a:noFill/>
-        </p:spPr>
-        <p:txBody>
-          <a:bodyPr wrap="square">
-            <a:spAutoFit/>
-          </a:bodyPr>
-          <a:lstStyle/>
-          <a:p>
-            <a:pPr>
-              <a:spcAft>
-                <a:spcPts val="400"/>
-              </a:spcAft>
-            </a:pPr>
-            <a:r>
-              <a:rPr sz="1400" b="0">
-                <a:solidFill>
-                  <a:srgbClr val="14213D"/>
-                </a:solidFill>
-                <a:latin typeface="Arial"/>
-              </a:rPr>
-              <a:t>Final report, replay demo video and a public GitHub repository.</a:t>
+            <a:off x="813599" y="5328000"/>
+            <a:ext cx="10908000" cy="288000"/>
+          </a:xfrm>
+          <a:prstGeom prst="rect">
+            <a:avLst/>
+          </a:prstGeom>
+          <a:noFill/>
+        </p:spPr>
+        <p:txBody>
+          <a:bodyPr wrap="square">
+            <a:spAutoFit/>
+          </a:bodyPr>
+          <a:lstStyle/>
+          <a:p>
+            <a:pPr>
+              <a:spcAft>
+                <a:spcPts val="400"/>
+              </a:spcAft>
+            </a:pPr>
+            <a:r>
+              <a:rPr sz="1000" b="0">
+                <a:solidFill>
+                  <a:srgbClr val="555F6D"/>
+                </a:solidFill>
+                <a:latin typeface="Arial"/>
+              </a:rPr>
+              <a:t>In a factory it would run between the AOI machine and the manual inspection station. Connecting it to a real line is not part of the course project. The command names are planned; the day-87 numbers come from our first replay (weekly retraining).</a:t>
             </a:r>
           </a:p>
         </p:txBody>
@@ -13609,7 +13721,7 @@
                 </a:solidFill>
                 <a:latin typeface="Arial"/>
               </a:rPr>
-              <a:t>After the semester</a:t>
+              <a:t>Next steps after the course</a:t>
             </a:r>
           </a:p>
         </p:txBody>
@@ -13796,7 +13908,7 @@
                 </a:solidFill>
                 <a:latin typeface="Arial"/>
               </a:rPr>
-              <a:t>More lines and plants</a:t>
+              <a:t>One gate per inspection type</a:t>
             </a:r>
           </a:p>
         </p:txBody>
@@ -13829,13 +13941,13 @@
               </a:spcAft>
             </a:pPr>
             <a:r>
-              <a:rPr sz="1400" b="0">
+              <a:rPr sz="1300" b="0">
                 <a:solidFill>
                   <a:srgbClr val="14213D"/>
                 </a:solidFill>
                 <a:latin typeface="Arial"/>
               </a:rPr>
-              <a:t>Test the gate on other AOI data to see how well it transfers</a:t>
+              <a:t>The data has 5 inspection types with very different defect rates; a separate threshold or model per type may release more false calls safely.</a:t>
             </a:r>
           </a:p>
         </p:txBody>
@@ -13920,7 +14032,7 @@
                 </a:solidFill>
                 <a:latin typeface="Arial"/>
               </a:rPr>
-              <a:t>Images + measurements</a:t>
+              <a:t>Threshold from real costs</a:t>
             </a:r>
           </a:p>
         </p:txBody>
@@ -13953,13 +14065,13 @@
               </a:spcAft>
             </a:pPr>
             <a:r>
-              <a:rPr sz="1400" b="0">
+              <a:rPr sz="1300" b="0">
                 <a:solidFill>
                   <a:srgbClr val="14213D"/>
                 </a:solidFill>
                 <a:latin typeface="Arial"/>
               </a:rPr>
-              <a:t>Combine AOI camera images with the measurements (multimodal, lecture p. 28–29)</a:t>
+              <a:t>Set the threshold from the cost of one manual check vs. one escaped defect, and report savings in operator hours.</a:t>
             </a:r>
           </a:p>
         </p:txBody>
@@ -14044,7 +14156,7 @@
                 </a:solidFill>
                 <a:latin typeface="Arial"/>
               </a:rPr>
-              <a:t>Learning on the live line</a:t>
+              <a:t>Suspicious labels</a:t>
             </a:r>
           </a:p>
         </p:txBody>
@@ -14077,13 +14189,13 @@
               </a:spcAft>
             </a:pPr>
             <a:r>
-              <a:rPr sz="1400" b="0">
+              <a:rPr sz="1300" b="0">
                 <a:solidFill>
                   <a:srgbClr val="14213D"/>
                 </a:solidFill>
                 <a:latin typeface="Arial"/>
               </a:rPr>
-              <a:t>Online updates from new manual-inspection results, with operator feedback</a:t>
+              <a:t>Find likely operator labelling errors and measure how much they limit the gate.</a:t>
             </a:r>
           </a:p>
         </p:txBody>
@@ -14168,7 +14280,7 @@
                 </a:solidFill>
                 <a:latin typeface="Arial"/>
               </a:rPr>
-              <a:t>Deployment</a:t>
+              <a:t>Shadow mode in a factory</a:t>
             </a:r>
           </a:p>
         </p:txBody>
@@ -14201,13 +14313,13 @@
               </a:spcAft>
             </a:pPr>
             <a:r>
-              <a:rPr sz="1400" b="0">
+              <a:rPr sz="1300" b="0">
                 <a:solidFill>
                   <a:srgbClr val="14213D"/>
                 </a:solidFill>
                 <a:latin typeface="Arial"/>
               </a:rPr>
-              <a:t>Run the gate at the inspection station, next to the AOI machine</a:t>
+              <a:t>The step before any real use: the gate runs next to the operators and only logs its decisions, so quality engineers can compare before it may release boards.</a:t>
             </a:r>
           </a:p>
         </p:txBody>

</xml_diff>

<commit_message>
Future work: industry partner, AOI interface, shadow mode
</commit_message>
<xml_diff>
--- a/docs/slides_revised_topic.pptx
+++ b/docs/slides_revised_topic.pptx
@@ -13721,7 +13721,7 @@
                 </a:solidFill>
                 <a:latin typeface="Arial"/>
               </a:rPr>
-              <a:t>Next steps after the course</a:t>
+              <a:t>From the public data set to a real line, with an industry partner</a:t>
             </a:r>
           </a:p>
         </p:txBody>
@@ -13837,7 +13837,7 @@
         <p:spPr>
           <a:xfrm>
             <a:off x="813599" y="1800000"/>
-            <a:ext cx="5364000" cy="1655999"/>
+            <a:ext cx="2484000" cy="2664000"/>
           </a:xfrm>
           <a:prstGeom prst="roundRect">
             <a:avLst>
@@ -13882,8 +13882,8 @@
         </p:nvSpPr>
         <p:spPr>
           <a:xfrm>
-            <a:off x="993599" y="1925999"/>
-            <a:ext cx="5004000" cy="360000"/>
+            <a:off x="957599" y="1908000"/>
+            <a:ext cx="2232000" cy="468000"/>
           </a:xfrm>
           <a:prstGeom prst="rect">
             <a:avLst/>
@@ -13908,7 +13908,7 @@
                 </a:solidFill>
                 <a:latin typeface="Arial"/>
               </a:rPr>
-              <a:t>One gate per inspection type</a:t>
+              <a:t>1 · Industry partner</a:t>
             </a:r>
           </a:p>
         </p:txBody>
@@ -13921,8 +13921,8 @@
         </p:nvSpPr>
         <p:spPr>
           <a:xfrm>
-            <a:off x="993599" y="2250000"/>
-            <a:ext cx="5004000" cy="1115999"/>
+            <a:off x="957599" y="2448000"/>
+            <a:ext cx="2232000" cy="1944000"/>
           </a:xfrm>
           <a:prstGeom prst="rect">
             <a:avLst/>
@@ -13941,27 +13941,404 @@
               </a:spcAft>
             </a:pPr>
             <a:r>
-              <a:rPr sz="1300" b="0">
+              <a:rPr sz="1200" b="0">
                 <a:solidFill>
                   <a:srgbClr val="14213D"/>
                 </a:solidFill>
                 <a:latin typeface="Arial"/>
               </a:rPr>
-              <a:t>The data has 5 inspection types with very different defect rates; a separate threshold or model per type may release more false calls safely.</a:t>
-            </a:r>
-          </a:p>
-        </p:txBody>
-      </p:sp>
-      <p:sp>
-        <p:nvSpPr>
-          <p:cNvPr id="10" name="Rounded Rectangle 9"/>
+              <a:t>An electronics plant (e.g. in Bavaria) shares AOI and manual-inspection records under a data agreement.</a:t>
+            </a:r>
+          </a:p>
+        </p:txBody>
+      </p:sp>
+      <p:sp>
+        <p:nvSpPr>
+          <p:cNvPr id="10" name="Right Arrow 9"/>
           <p:cNvSpPr/>
           <p:nvPr/>
         </p:nvSpPr>
         <p:spPr>
           <a:xfrm>
-            <a:off x="6357599" y="1800000"/>
-            <a:ext cx="5364000" cy="1655999"/>
+            <a:off x="3315599" y="2988000"/>
+            <a:ext cx="270000" cy="288000"/>
+          </a:xfrm>
+          <a:prstGeom prst="rightArrow">
+            <a:avLst/>
+          </a:prstGeom>
+          <a:solidFill>
+            <a:srgbClr val="2F6DB5"/>
+          </a:solidFill>
+          <a:ln>
+            <a:noFill/>
+          </a:ln>
+        </p:spPr>
+        <p:style>
+          <a:lnRef idx="1">
+            <a:schemeClr val="accent1"/>
+          </a:lnRef>
+          <a:fillRef idx="3">
+            <a:schemeClr val="accent1"/>
+          </a:fillRef>
+          <a:effectRef idx="2">
+            <a:schemeClr val="accent1"/>
+          </a:effectRef>
+          <a:fontRef idx="minor">
+            <a:schemeClr val="lt1"/>
+          </a:fontRef>
+        </p:style>
+        <p:txBody>
+          <a:bodyPr rtlCol="0" anchor="ctr"/>
+          <a:lstStyle/>
+          <a:p>
+            <a:pPr algn="ctr"/>
+          </a:p>
+        </p:txBody>
+      </p:sp>
+      <p:sp>
+        <p:nvSpPr>
+          <p:cNvPr id="11" name="Rounded Rectangle 10"/>
+          <p:cNvSpPr/>
+          <p:nvPr/>
+        </p:nvSpPr>
+        <p:spPr>
+          <a:xfrm>
+            <a:off x="3603599" y="1800000"/>
+            <a:ext cx="2484000" cy="2664000"/>
+          </a:xfrm>
+          <a:prstGeom prst="roundRect">
+            <a:avLst>
+              <a:gd name="adj" fmla="val 6000"/>
+            </a:avLst>
+          </a:prstGeom>
+          <a:solidFill>
+            <a:srgbClr val="DCE7F5"/>
+          </a:solidFill>
+          <a:ln>
+            <a:noFill/>
+          </a:ln>
+          <a:effectLst/>
+        </p:spPr>
+        <p:style>
+          <a:lnRef idx="1">
+            <a:schemeClr val="accent1"/>
+          </a:lnRef>
+          <a:fillRef idx="3">
+            <a:schemeClr val="accent1"/>
+          </a:fillRef>
+          <a:effectRef idx="2">
+            <a:schemeClr val="accent1"/>
+          </a:effectRef>
+          <a:fontRef idx="minor">
+            <a:schemeClr val="lt1"/>
+          </a:fontRef>
+        </p:style>
+        <p:txBody>
+          <a:bodyPr rtlCol="0" anchor="ctr"/>
+          <a:lstStyle/>
+          <a:p>
+            <a:pPr algn="ctr"/>
+          </a:p>
+        </p:txBody>
+      </p:sp>
+      <p:sp>
+        <p:nvSpPr>
+          <p:cNvPr id="12" name="TextBox 11"/>
+          <p:cNvSpPr txBox="1"/>
+          <p:nvPr/>
+        </p:nvSpPr>
+        <p:spPr>
+          <a:xfrm>
+            <a:off x="3747599" y="1908000"/>
+            <a:ext cx="2232000" cy="468000"/>
+          </a:xfrm>
+          <a:prstGeom prst="rect">
+            <a:avLst/>
+          </a:prstGeom>
+          <a:noFill/>
+        </p:spPr>
+        <p:txBody>
+          <a:bodyPr wrap="square">
+            <a:spAutoFit/>
+          </a:bodyPr>
+          <a:lstStyle/>
+          <a:p>
+            <a:pPr>
+              <a:spcAft>
+                <a:spcPts val="400"/>
+              </a:spcAft>
+            </a:pPr>
+            <a:r>
+              <a:rPr sz="1500" b="1">
+                <a:solidFill>
+                  <a:srgbClr val="2F6DB5"/>
+                </a:solidFill>
+                <a:latin typeface="Arial"/>
+              </a:rPr>
+              <a:t>2 · AOI interface</a:t>
+            </a:r>
+          </a:p>
+        </p:txBody>
+      </p:sp>
+      <p:sp>
+        <p:nvSpPr>
+          <p:cNvPr id="13" name="TextBox 12"/>
+          <p:cNvSpPr txBox="1"/>
+          <p:nvPr/>
+        </p:nvSpPr>
+        <p:spPr>
+          <a:xfrm>
+            <a:off x="3747599" y="2448000"/>
+            <a:ext cx="2232000" cy="1944000"/>
+          </a:xfrm>
+          <a:prstGeom prst="rect">
+            <a:avLst/>
+          </a:prstGeom>
+          <a:noFill/>
+        </p:spPr>
+        <p:txBody>
+          <a:bodyPr wrap="square">
+            <a:spAutoFit/>
+          </a:bodyPr>
+          <a:lstStyle/>
+          <a:p>
+            <a:pPr>
+              <a:spcAft>
+                <a:spcPts val="400"/>
+              </a:spcAft>
+            </a:pPr>
+            <a:r>
+              <a:rPr sz="1200" b="0">
+                <a:solidFill>
+                  <a:srgbClr val="14213D"/>
+                </a:solidFill>
+                <a:latin typeface="Arial"/>
+              </a:rPr>
+              <a:t>Read each board’s AOI result from the machine or MES (e.g. IPC-CFX standard or vendor export); send the decision to the repair station.</a:t>
+            </a:r>
+          </a:p>
+        </p:txBody>
+      </p:sp>
+      <p:sp>
+        <p:nvSpPr>
+          <p:cNvPr id="14" name="Right Arrow 13"/>
+          <p:cNvSpPr/>
+          <p:nvPr/>
+        </p:nvSpPr>
+        <p:spPr>
+          <a:xfrm>
+            <a:off x="6105599" y="2988000"/>
+            <a:ext cx="270000" cy="288000"/>
+          </a:xfrm>
+          <a:prstGeom prst="rightArrow">
+            <a:avLst/>
+          </a:prstGeom>
+          <a:solidFill>
+            <a:srgbClr val="2F6DB5"/>
+          </a:solidFill>
+          <a:ln>
+            <a:noFill/>
+          </a:ln>
+        </p:spPr>
+        <p:style>
+          <a:lnRef idx="1">
+            <a:schemeClr val="accent1"/>
+          </a:lnRef>
+          <a:fillRef idx="3">
+            <a:schemeClr val="accent1"/>
+          </a:fillRef>
+          <a:effectRef idx="2">
+            <a:schemeClr val="accent1"/>
+          </a:effectRef>
+          <a:fontRef idx="minor">
+            <a:schemeClr val="lt1"/>
+          </a:fontRef>
+        </p:style>
+        <p:txBody>
+          <a:bodyPr rtlCol="0" anchor="ctr"/>
+          <a:lstStyle/>
+          <a:p>
+            <a:pPr algn="ctr"/>
+          </a:p>
+        </p:txBody>
+      </p:sp>
+      <p:sp>
+        <p:nvSpPr>
+          <p:cNvPr id="15" name="Rounded Rectangle 14"/>
+          <p:cNvSpPr/>
+          <p:nvPr/>
+        </p:nvSpPr>
+        <p:spPr>
+          <a:xfrm>
+            <a:off x="6393599" y="1800000"/>
+            <a:ext cx="2484000" cy="2664000"/>
+          </a:xfrm>
+          <a:prstGeom prst="roundRect">
+            <a:avLst>
+              <a:gd name="adj" fmla="val 6000"/>
+            </a:avLst>
+          </a:prstGeom>
+          <a:solidFill>
+            <a:srgbClr val="DCE7F5"/>
+          </a:solidFill>
+          <a:ln>
+            <a:noFill/>
+          </a:ln>
+          <a:effectLst/>
+        </p:spPr>
+        <p:style>
+          <a:lnRef idx="1">
+            <a:schemeClr val="accent1"/>
+          </a:lnRef>
+          <a:fillRef idx="3">
+            <a:schemeClr val="accent1"/>
+          </a:fillRef>
+          <a:effectRef idx="2">
+            <a:schemeClr val="accent1"/>
+          </a:effectRef>
+          <a:fontRef idx="minor">
+            <a:schemeClr val="lt1"/>
+          </a:fontRef>
+        </p:style>
+        <p:txBody>
+          <a:bodyPr rtlCol="0" anchor="ctr"/>
+          <a:lstStyle/>
+          <a:p>
+            <a:pPr algn="ctr"/>
+          </a:p>
+        </p:txBody>
+      </p:sp>
+      <p:sp>
+        <p:nvSpPr>
+          <p:cNvPr id="16" name="TextBox 15"/>
+          <p:cNvSpPr txBox="1"/>
+          <p:nvPr/>
+        </p:nvSpPr>
+        <p:spPr>
+          <a:xfrm>
+            <a:off x="6537599" y="1908000"/>
+            <a:ext cx="2232000" cy="468000"/>
+          </a:xfrm>
+          <a:prstGeom prst="rect">
+            <a:avLst/>
+          </a:prstGeom>
+          <a:noFill/>
+        </p:spPr>
+        <p:txBody>
+          <a:bodyPr wrap="square">
+            <a:spAutoFit/>
+          </a:bodyPr>
+          <a:lstStyle/>
+          <a:p>
+            <a:pPr>
+              <a:spcAft>
+                <a:spcPts val="400"/>
+              </a:spcAft>
+            </a:pPr>
+            <a:r>
+              <a:rPr sz="1500" b="1">
+                <a:solidFill>
+                  <a:srgbClr val="2F6DB5"/>
+                </a:solidFill>
+                <a:latin typeface="Arial"/>
+              </a:rPr>
+              <a:t>3 · Shadow mode</a:t>
+            </a:r>
+          </a:p>
+        </p:txBody>
+      </p:sp>
+      <p:sp>
+        <p:nvSpPr>
+          <p:cNvPr id="17" name="TextBox 16"/>
+          <p:cNvSpPr txBox="1"/>
+          <p:nvPr/>
+        </p:nvSpPr>
+        <p:spPr>
+          <a:xfrm>
+            <a:off x="6537599" y="2448000"/>
+            <a:ext cx="2232000" cy="1944000"/>
+          </a:xfrm>
+          <a:prstGeom prst="rect">
+            <a:avLst/>
+          </a:prstGeom>
+          <a:noFill/>
+        </p:spPr>
+        <p:txBody>
+          <a:bodyPr wrap="square">
+            <a:spAutoFit/>
+          </a:bodyPr>
+          <a:lstStyle/>
+          <a:p>
+            <a:pPr>
+              <a:spcAft>
+                <a:spcPts val="400"/>
+              </a:spcAft>
+            </a:pPr>
+            <a:r>
+              <a:rPr sz="1200" b="0">
+                <a:solidFill>
+                  <a:srgbClr val="14213D"/>
+                </a:solidFill>
+                <a:latin typeface="Arial"/>
+              </a:rPr>
+              <a:t>The gate runs next to the operators on real data and only logs its decisions; nothing is released yet.</a:t>
+            </a:r>
+          </a:p>
+        </p:txBody>
+      </p:sp>
+      <p:sp>
+        <p:nvSpPr>
+          <p:cNvPr id="18" name="Right Arrow 17"/>
+          <p:cNvSpPr/>
+          <p:nvPr/>
+        </p:nvSpPr>
+        <p:spPr>
+          <a:xfrm>
+            <a:off x="8895599" y="2988000"/>
+            <a:ext cx="270000" cy="288000"/>
+          </a:xfrm>
+          <a:prstGeom prst="rightArrow">
+            <a:avLst/>
+          </a:prstGeom>
+          <a:solidFill>
+            <a:srgbClr val="2F6DB5"/>
+          </a:solidFill>
+          <a:ln>
+            <a:noFill/>
+          </a:ln>
+        </p:spPr>
+        <p:style>
+          <a:lnRef idx="1">
+            <a:schemeClr val="accent1"/>
+          </a:lnRef>
+          <a:fillRef idx="3">
+            <a:schemeClr val="accent1"/>
+          </a:fillRef>
+          <a:effectRef idx="2">
+            <a:schemeClr val="accent1"/>
+          </a:effectRef>
+          <a:fontRef idx="minor">
+            <a:schemeClr val="lt1"/>
+          </a:fontRef>
+        </p:style>
+        <p:txBody>
+          <a:bodyPr rtlCol="0" anchor="ctr"/>
+          <a:lstStyle/>
+          <a:p>
+            <a:pPr algn="ctr"/>
+          </a:p>
+        </p:txBody>
+      </p:sp>
+      <p:sp>
+        <p:nvSpPr>
+          <p:cNvPr id="19" name="Rounded Rectangle 18"/>
+          <p:cNvSpPr/>
+          <p:nvPr/>
+        </p:nvSpPr>
+        <p:spPr>
+          <a:xfrm>
+            <a:off x="9183599" y="1800000"/>
+            <a:ext cx="2484000" cy="2664000"/>
           </a:xfrm>
           <a:prstGeom prst="roundRect">
             <a:avLst>
@@ -14000,14 +14377,14 @@
       </p:sp>
       <p:sp>
         <p:nvSpPr>
-          <p:cNvPr id="11" name="TextBox 10"/>
-          <p:cNvSpPr txBox="1"/>
-          <p:nvPr/>
-        </p:nvSpPr>
-        <p:spPr>
-          <a:xfrm>
-            <a:off x="6537599" y="1925999"/>
-            <a:ext cx="5004000" cy="360000"/>
+          <p:cNvPr id="20" name="TextBox 19"/>
+          <p:cNvSpPr txBox="1"/>
+          <p:nvPr/>
+        </p:nvSpPr>
+        <p:spPr>
+          <a:xfrm>
+            <a:off x="9327599" y="1908000"/>
+            <a:ext cx="2232000" cy="468000"/>
           </a:xfrm>
           <a:prstGeom prst="rect">
             <a:avLst/>
@@ -14032,21 +14409,21 @@
                 </a:solidFill>
                 <a:latin typeface="Arial"/>
               </a:rPr>
-              <a:t>Threshold from real costs</a:t>
-            </a:r>
-          </a:p>
-        </p:txBody>
-      </p:sp>
-      <p:sp>
-        <p:nvSpPr>
-          <p:cNvPr id="12" name="TextBox 11"/>
-          <p:cNvSpPr txBox="1"/>
-          <p:nvPr/>
-        </p:nvSpPr>
-        <p:spPr>
-          <a:xfrm>
-            <a:off x="6537599" y="2250000"/>
-            <a:ext cx="5004000" cy="1115999"/>
+              <a:t>4 · Approval, go-live</a:t>
+            </a:r>
+          </a:p>
+        </p:txBody>
+      </p:sp>
+      <p:sp>
+        <p:nvSpPr>
+          <p:cNvPr id="21" name="TextBox 20"/>
+          <p:cNvSpPr txBox="1"/>
+          <p:nvPr/>
+        </p:nvSpPr>
+        <p:spPr>
+          <a:xfrm>
+            <a:off x="9327599" y="2448000"/>
+            <a:ext cx="2232000" cy="1944000"/>
           </a:xfrm>
           <a:prstGeom prst="rect">
             <a:avLst/>
@@ -14065,27 +14442,27 @@
               </a:spcAft>
             </a:pPr>
             <a:r>
-              <a:rPr sz="1300" b="0">
+              <a:rPr sz="1200" b="0">
                 <a:solidFill>
                   <a:srgbClr val="14213D"/>
                 </a:solidFill>
                 <a:latin typeface="Arial"/>
               </a:rPr>
-              <a:t>Set the threshold from the cost of one manual check vs. one escaped defect, and report savings in operator hours.</a:t>
-            </a:r>
-          </a:p>
-        </p:txBody>
-      </p:sp>
-      <p:sp>
-        <p:nvSpPr>
-          <p:cNvPr id="13" name="Rounded Rectangle 12"/>
+              <a:t>Quality engineers compare the logs; if ≤ 1 % defects would have been released, start with one inspection type.</a:t>
+            </a:r>
+          </a:p>
+        </p:txBody>
+      </p:sp>
+      <p:sp>
+        <p:nvSpPr>
+          <p:cNvPr id="22" name="Rounded Rectangle 21"/>
           <p:cNvSpPr/>
           <p:nvPr/>
         </p:nvSpPr>
         <p:spPr>
           <a:xfrm>
-            <a:off x="813599" y="3635999"/>
-            <a:ext cx="5364000" cy="1655999"/>
+            <a:off x="813599" y="4644000"/>
+            <a:ext cx="10908000" cy="792000"/>
           </a:xfrm>
           <a:prstGeom prst="roundRect">
             <a:avLst>
@@ -14093,7 +14470,7 @@
             </a:avLst>
           </a:prstGeom>
           <a:solidFill>
-            <a:srgbClr val="FFFFFF"/>
+            <a:srgbClr val="14213D"/>
           </a:solidFill>
           <a:ln>
             <a:noFill/>
@@ -14124,61 +14501,22 @@
       </p:sp>
       <p:sp>
         <p:nvSpPr>
-          <p:cNvPr id="14" name="TextBox 13"/>
-          <p:cNvSpPr txBox="1"/>
-          <p:nvPr/>
-        </p:nvSpPr>
-        <p:spPr>
-          <a:xfrm>
-            <a:off x="993599" y="3761998"/>
-            <a:ext cx="5004000" cy="360000"/>
-          </a:xfrm>
-          <a:prstGeom prst="rect">
-            <a:avLst/>
-          </a:prstGeom>
-          <a:noFill/>
-        </p:spPr>
-        <p:txBody>
-          <a:bodyPr wrap="square">
-            <a:spAutoFit/>
-          </a:bodyPr>
-          <a:lstStyle/>
-          <a:p>
-            <a:pPr>
-              <a:spcAft>
-                <a:spcPts val="400"/>
-              </a:spcAft>
-            </a:pPr>
-            <a:r>
-              <a:rPr sz="1500" b="1">
-                <a:solidFill>
-                  <a:srgbClr val="2F6DB5"/>
-                </a:solidFill>
-                <a:latin typeface="Arial"/>
-              </a:rPr>
-              <a:t>Suspicious labels</a:t>
-            </a:r>
-          </a:p>
-        </p:txBody>
-      </p:sp>
-      <p:sp>
-        <p:nvSpPr>
-          <p:cNvPr id="15" name="TextBox 14"/>
-          <p:cNvSpPr txBox="1"/>
-          <p:nvPr/>
-        </p:nvSpPr>
-        <p:spPr>
-          <a:xfrm>
-            <a:off x="993599" y="4085999"/>
-            <a:ext cx="5004000" cy="1115999"/>
-          </a:xfrm>
-          <a:prstGeom prst="rect">
-            <a:avLst/>
-          </a:prstGeom>
-          <a:noFill/>
-        </p:spPr>
-        <p:txBody>
-          <a:bodyPr wrap="square">
+          <p:cNvPr id="23" name="TextBox 22"/>
+          <p:cNvSpPr txBox="1"/>
+          <p:nvPr/>
+        </p:nvSpPr>
+        <p:spPr>
+          <a:xfrm>
+            <a:off x="993599" y="4644000"/>
+            <a:ext cx="10548000" cy="792000"/>
+          </a:xfrm>
+          <a:prstGeom prst="rect">
+            <a:avLst/>
+          </a:prstGeom>
+          <a:noFill/>
+        </p:spPr>
+        <p:txBody>
+          <a:bodyPr wrap="square" anchor="ctr">
             <a:spAutoFit/>
           </a:bodyPr>
           <a:lstStyle/>
@@ -14191,135 +14529,11 @@
             <a:r>
               <a:rPr sz="1300" b="0">
                 <a:solidFill>
-                  <a:srgbClr val="14213D"/>
-                </a:solidFill>
-                <a:latin typeface="Arial"/>
-              </a:rPr>
-              <a:t>Find likely operator labelling errors and measure how much they limit the gate.</a:t>
-            </a:r>
-          </a:p>
-        </p:txBody>
-      </p:sp>
-      <p:sp>
-        <p:nvSpPr>
-          <p:cNvPr id="16" name="Rounded Rectangle 15"/>
-          <p:cNvSpPr/>
-          <p:nvPr/>
-        </p:nvSpPr>
-        <p:spPr>
-          <a:xfrm>
-            <a:off x="6357599" y="3635999"/>
-            <a:ext cx="5364000" cy="1655999"/>
-          </a:xfrm>
-          <a:prstGeom prst="roundRect">
-            <a:avLst>
-              <a:gd name="adj" fmla="val 6000"/>
-            </a:avLst>
-          </a:prstGeom>
-          <a:solidFill>
-            <a:srgbClr val="FFFFFF"/>
-          </a:solidFill>
-          <a:ln>
-            <a:noFill/>
-          </a:ln>
-          <a:effectLst/>
-        </p:spPr>
-        <p:style>
-          <a:lnRef idx="1">
-            <a:schemeClr val="accent1"/>
-          </a:lnRef>
-          <a:fillRef idx="3">
-            <a:schemeClr val="accent1"/>
-          </a:fillRef>
-          <a:effectRef idx="2">
-            <a:schemeClr val="accent1"/>
-          </a:effectRef>
-          <a:fontRef idx="minor">
-            <a:schemeClr val="lt1"/>
-          </a:fontRef>
-        </p:style>
-        <p:txBody>
-          <a:bodyPr rtlCol="0" anchor="ctr"/>
-          <a:lstStyle/>
-          <a:p>
-            <a:pPr algn="ctr"/>
-          </a:p>
-        </p:txBody>
-      </p:sp>
-      <p:sp>
-        <p:nvSpPr>
-          <p:cNvPr id="17" name="TextBox 16"/>
-          <p:cNvSpPr txBox="1"/>
-          <p:nvPr/>
-        </p:nvSpPr>
-        <p:spPr>
-          <a:xfrm>
-            <a:off x="6537599" y="3761998"/>
-            <a:ext cx="5004000" cy="360000"/>
-          </a:xfrm>
-          <a:prstGeom prst="rect">
-            <a:avLst/>
-          </a:prstGeom>
-          <a:noFill/>
-        </p:spPr>
-        <p:txBody>
-          <a:bodyPr wrap="square">
-            <a:spAutoFit/>
-          </a:bodyPr>
-          <a:lstStyle/>
-          <a:p>
-            <a:pPr>
-              <a:spcAft>
-                <a:spcPts val="400"/>
-              </a:spcAft>
-            </a:pPr>
-            <a:r>
-              <a:rPr sz="1500" b="1">
-                <a:solidFill>
-                  <a:srgbClr val="2F6DB5"/>
-                </a:solidFill>
-                <a:latin typeface="Arial"/>
-              </a:rPr>
-              <a:t>Shadow mode in a factory</a:t>
-            </a:r>
-          </a:p>
-        </p:txBody>
-      </p:sp>
-      <p:sp>
-        <p:nvSpPr>
-          <p:cNvPr id="18" name="TextBox 17"/>
-          <p:cNvSpPr txBox="1"/>
-          <p:nvPr/>
-        </p:nvSpPr>
-        <p:spPr>
-          <a:xfrm>
-            <a:off x="6537599" y="4085999"/>
-            <a:ext cx="5004000" cy="1115999"/>
-          </a:xfrm>
-          <a:prstGeom prst="rect">
-            <a:avLst/>
-          </a:prstGeom>
-          <a:noFill/>
-        </p:spPr>
-        <p:txBody>
-          <a:bodyPr wrap="square">
-            <a:spAutoFit/>
-          </a:bodyPr>
-          <a:lstStyle/>
-          <a:p>
-            <a:pPr>
-              <a:spcAft>
-                <a:spcPts val="400"/>
-              </a:spcAft>
-            </a:pPr>
-            <a:r>
-              <a:rPr sz="1300" b="0">
-                <a:solidFill>
-                  <a:srgbClr val="14213D"/>
-                </a:solidFill>
-                <a:latin typeface="Arial"/>
-              </a:rPr>
-              <a:t>The step before any real use: the gate runs next to the operators and only logs its decisions, so quality engineers can compare before it may release boards.</a:t>
+                  <a:srgbClr val="FFFFFF"/>
+                </a:solidFill>
+                <a:latin typeface="Arial"/>
+              </a:rPr>
+              <a:t>Open questions for this step: interface development per AOI vendor, data access and agreements, and approval by the plant’s quality department.</a:t>
             </a:r>
           </a:p>
         </p:txBody>

</xml_diff>

<commit_message>
Title aligned with lecture example: AI-powered Quality Control and Defect Detection in Electronics Assembly
</commit_message>
<xml_diff>
--- a/docs/slides_revised_topic.pptx
+++ b/docs/slides_revised_topic.pptx
@@ -3206,8 +3206,8 @@
         </p:nvSpPr>
         <p:spPr>
           <a:xfrm>
-            <a:off x="813599" y="2232000"/>
-            <a:ext cx="10908000" cy="900000"/>
+            <a:off x="813599" y="1944000"/>
+            <a:ext cx="10908000" cy="1440000"/>
           </a:xfrm>
           <a:prstGeom prst="rect">
             <a:avLst/>
@@ -3226,13 +3226,13 @@
               </a:spcAft>
             </a:pPr>
             <a:r>
-              <a:rPr sz="5400" b="1">
+              <a:rPr sz="4000" b="1">
                 <a:solidFill>
                   <a:srgbClr val="FFFFFF"/>
                 </a:solidFill>
                 <a:latin typeface="Arial"/>
               </a:rPr>
-              <a:t>AOI Decision Gate</a:t>
+              <a:t>AI-powered Quality Control and Defect Detection in Electronics Assembly</a:t>
             </a:r>
           </a:p>
         </p:txBody>
@@ -3245,7 +3245,7 @@
         </p:nvSpPr>
         <p:spPr>
           <a:xfrm>
-            <a:off x="813599" y="3240000"/>
+            <a:off x="813599" y="3744000"/>
             <a:ext cx="10908000" cy="720000"/>
           </a:xfrm>
           <a:prstGeom prst="rect">
@@ -3271,7 +3271,7 @@
                 </a:solidFill>
                 <a:latin typeface="Arial"/>
               </a:rPr>
-              <a:t>AI decision gate for false-call reduction in automated optical inspection of electronics assembly</a:t>
+              <a:t>Reducing false calls of automated optical inspection (AOI) with Siemens production data</a:t>
             </a:r>
           </a:p>
         </p:txBody>
@@ -3516,7 +3516,7 @@
                 </a:solidFill>
                 <a:latin typeface="Arial"/>
               </a:rPr>
-              <a:t>AOI Decision Gate · Team 1</a:t>
+              <a:t>AI-powered Quality Control and Defect Detection · Team 1</a:t>
             </a:r>
           </a:p>
         </p:txBody>
@@ -4622,7 +4622,7 @@
                 </a:solidFill>
                 <a:latin typeface="Arial"/>
               </a:rPr>
-              <a:t>AOI Decision Gate · Team 1</a:t>
+              <a:t>AI-powered Quality Control and Defect Detection · Team 1</a:t>
             </a:r>
           </a:p>
         </p:txBody>
@@ -5696,7 +5696,7 @@
                 </a:solidFill>
                 <a:latin typeface="Arial"/>
               </a:rPr>
-              <a:t>AOI Decision Gate · Team 1</a:t>
+              <a:t>AI-powered Quality Control and Defect Detection · Team 1</a:t>
             </a:r>
           </a:p>
         </p:txBody>
@@ -6512,7 +6512,7 @@
                 </a:solidFill>
                 <a:latin typeface="Arial"/>
               </a:rPr>
-              <a:t>AOI Decision Gate · Team 1</a:t>
+              <a:t>AI-powered Quality Control and Defect Detection · Team 1</a:t>
             </a:r>
           </a:p>
         </p:txBody>
@@ -6914,7 +6914,7 @@
                 </a:solidFill>
                 <a:latin typeface="Arial"/>
               </a:rPr>
-              <a:t>AOI Decision Gate · Team 1</a:t>
+              <a:t>AI-powered Quality Control and Defect Detection · Team 1</a:t>
             </a:r>
           </a:p>
         </p:txBody>
@@ -7316,7 +7316,7 @@
                 </a:solidFill>
                 <a:latin typeface="Arial"/>
               </a:rPr>
-              <a:t>AOI Decision Gate · Team 1</a:t>
+              <a:t>AI-powered Quality Control and Defect Detection · Team 1</a:t>
             </a:r>
           </a:p>
         </p:txBody>
@@ -8146,7 +8146,7 @@
                 </a:solidFill>
                 <a:latin typeface="Arial"/>
               </a:rPr>
-              <a:t>AOI Decision Gate · Team 1</a:t>
+              <a:t>AI-powered Quality Control and Defect Detection · Team 1</a:t>
             </a:r>
           </a:p>
         </p:txBody>
@@ -8848,7 +8848,7 @@
                 </a:solidFill>
                 <a:latin typeface="Arial"/>
               </a:rPr>
-              <a:t>AOI Decision Gate · Team 1</a:t>
+              <a:t>AI-powered Quality Control and Defect Detection · Team 1</a:t>
             </a:r>
           </a:p>
         </p:txBody>
@@ -9557,7 +9557,7 @@
                 </a:solidFill>
                 <a:latin typeface="Arial"/>
               </a:rPr>
-              <a:t>AOI Decision Gate · Team 1</a:t>
+              <a:t>AI-powered Quality Control and Defect Detection · Team 1</a:t>
             </a:r>
           </a:p>
         </p:txBody>
@@ -9787,7 +9787,7 @@
                 </a:solidFill>
                 <a:latin typeface="Arial"/>
               </a:rPr>
-              <a:t>AOI Decision Gate · Team 1</a:t>
+              <a:t>AI-powered Quality Control and Defect Detection · Team 1</a:t>
             </a:r>
           </a:p>
         </p:txBody>
@@ -10601,7 +10601,7 @@
                 </a:solidFill>
                 <a:latin typeface="Arial"/>
               </a:rPr>
-              <a:t>AOI Decision Gate · Team 1</a:t>
+              <a:t>AI-powered Quality Control and Defect Detection · Team 1</a:t>
             </a:r>
           </a:p>
         </p:txBody>
@@ -11929,7 +11929,7 @@
                 </a:solidFill>
                 <a:latin typeface="Arial"/>
               </a:rPr>
-              <a:t>AOI Decision Gate · Team 1</a:t>
+              <a:t>AI-powered Quality Control and Defect Detection · Team 1</a:t>
             </a:r>
           </a:p>
         </p:txBody>
@@ -12652,7 +12652,7 @@
                 </a:solidFill>
                 <a:latin typeface="Arial"/>
               </a:rPr>
-              <a:t>AOI Decision Gate · Team 1</a:t>
+              <a:t>AI-powered Quality Control and Defect Detection · Team 1</a:t>
             </a:r>
           </a:p>
         </p:txBody>
@@ -13218,7 +13218,7 @@
                 </a:solidFill>
                 <a:latin typeface="Arial"/>
               </a:rPr>
-              <a:t>AOI Decision Gate · Team 1</a:t>
+              <a:t>AI-powered Quality Control and Defect Detection · Team 1</a:t>
             </a:r>
           </a:p>
         </p:txBody>
@@ -13784,7 +13784,7 @@
                 </a:solidFill>
                 <a:latin typeface="Arial"/>
               </a:rPr>
-              <a:t>AOI Decision Gate · Team 1</a:t>
+              <a:t>AI-powered Quality Control and Defect Detection · Team 1</a:t>
             </a:r>
           </a:p>
         </p:txBody>
@@ -14700,7 +14700,7 @@
                 </a:solidFill>
                 <a:latin typeface="Arial"/>
               </a:rPr>
-              <a:t>AOI Decision Gate · Team 1</a:t>
+              <a:t>AI-powered Quality Control and Defect Detection · Team 1</a:t>
             </a:r>
           </a:p>
         </p:txBody>
@@ -15184,7 +15184,7 @@
                 </a:solidFill>
                 <a:latin typeface="Arial"/>
               </a:rPr>
-              <a:t>AOI Decision Gate · Team 1</a:t>
+              <a:t>AI-powered Quality Control and Defect Detection · Team 1</a:t>
             </a:r>
           </a:p>
         </p:txBody>
@@ -15849,7 +15849,7 @@
                 </a:solidFill>
                 <a:latin typeface="Arial"/>
               </a:rPr>
-              <a:t>AOI Decision Gate · Team 1</a:t>
+              <a:t>AI-powered Quality Control and Defect Detection · Team 1</a:t>
             </a:r>
           </a:p>
         </p:txBody>
@@ -16539,7 +16539,7 @@
                 </a:solidFill>
                 <a:latin typeface="Arial"/>
               </a:rPr>
-              <a:t>AOI Decision Gate · Team 1</a:t>
+              <a:t>AI-powered Quality Control and Defect Detection · Team 1</a:t>
             </a:r>
           </a:p>
         </p:txBody>
@@ -17234,7 +17234,7 @@
                 </a:solidFill>
                 <a:latin typeface="Arial"/>
               </a:rPr>
-              <a:t>AOI Decision Gate · Team 1</a:t>
+              <a:t>AI-powered Quality Control and Defect Detection · Team 1</a:t>
             </a:r>
           </a:p>
         </p:txBody>
@@ -18060,7 +18060,7 @@
                 </a:solidFill>
                 <a:latin typeface="Arial"/>
               </a:rPr>
-              <a:t>AOI Decision Gate · Team 1</a:t>
+              <a:t>AI-powered Quality Control and Defect Detection · Team 1</a:t>
             </a:r>
           </a:p>
         </p:txBody>
@@ -18886,7 +18886,7 @@
                 </a:solidFill>
                 <a:latin typeface="Arial"/>
               </a:rPr>
-              <a:t>AOI Decision Gate · Team 1</a:t>
+              <a:t>AI-powered Quality Control and Defect Detection · Team 1</a:t>
             </a:r>
           </a:p>
         </p:txBody>
@@ -20347,7 +20347,7 @@
                 </a:solidFill>
                 <a:latin typeface="Arial"/>
               </a:rPr>
-              <a:t>AOI Decision Gate · Team 1</a:t>
+              <a:t>AI-powered Quality Control and Defect Detection · Team 1</a:t>
             </a:r>
           </a:p>
         </p:txBody>

</xml_diff>

<commit_message>
Proposal, slides and README worded along the lecture slides and example concept presentation
</commit_message>
<xml_diff>
--- a/docs/slides_revised_topic.pptx
+++ b/docs/slides_revised_topic.pptx
@@ -7479,7 +7479,7 @@
                 </a:solidFill>
                 <a:latin typeface="Arial"/>
               </a:rPr>
-              <a:t>Download the Siemens AOI data, check checksum</a:t>
+              <a:t>Collected Siemens AOI data: flagged boards, defective &amp; false call (done)</a:t>
             </a:r>
           </a:p>
           <a:p>
@@ -7495,7 +7495,7 @@
                 </a:solidFill>
                 <a:latin typeface="Arial"/>
               </a:rPr>
-              <a:t>Group solder joints into boards; encode categories</a:t>
+              <a:t>Grouped solder joints into boards; encoded categories</a:t>
             </a:r>
           </a:p>
           <a:p>
@@ -7511,7 +7511,7 @@
                 </a:solidFill>
                 <a:latin typeface="Arial"/>
               </a:rPr>
-              <a:t>Keep strict time order; facts on imbalance and drift (done)</a:t>
+              <a:t>Split data strictly by time into train, validate, test sets</a:t>
             </a:r>
           </a:p>
         </p:txBody>
@@ -7635,7 +7635,7 @@
                 </a:solidFill>
                 <a:latin typeface="Arial"/>
               </a:rPr>
-              <a:t>Gradient-boosted trees as baseline (running)</a:t>
+              <a:t>Trained gradient-boosted trees as baseline (running)</a:t>
             </a:r>
           </a:p>
           <a:p>
@@ -7651,7 +7651,7 @@
                 </a:solidFill>
                 <a:latin typeface="Arial"/>
               </a:rPr>
-              <a:t>Neural network in PyTorch</a:t>
+              <a:t>Neural network in PyTorch; tuned key parameters</a:t>
             </a:r>
           </a:p>
           <a:p>
@@ -7791,7 +7791,7 @@
                 </a:solidFill>
                 <a:latin typeface="Arial"/>
               </a:rPr>
-              <a:t>Replay the line day by day, models trained on past days only</a:t>
+              <a:t>Simulated the line day by day (models trained on past days only)</a:t>
             </a:r>
           </a:p>
           <a:p>
@@ -7807,7 +7807,7 @@
                 </a:solidFill>
                 <a:latin typeface="Arial"/>
               </a:rPr>
-              <a:t>Compare update policies; add drift alarm</a:t>
+              <a:t>Integrated the models for decision routing; drift alarm</a:t>
             </a:r>
           </a:p>
           <a:p>
@@ -7823,7 +7823,7 @@
                 </a:solidFill>
                 <a:latin typeface="Arial"/>
               </a:rPr>
-              <a:t>Count released false calls and released defects per day</a:t>
+              <a:t>Boards are virtually routed to release or manual inspection</a:t>
             </a:r>
           </a:p>
         </p:txBody>
@@ -7947,7 +7947,7 @@
                 </a:solidFill>
                 <a:latin typeface="Arial"/>
               </a:rPr>
-              <a:t>Production KPIs per model and policy</a:t>
+              <a:t>Analyzed precision, recall, defects released, inspections saved</a:t>
             </a:r>
           </a:p>
           <a:p>
@@ -7963,7 +7963,7 @@
                 </a:solidFill>
                 <a:latin typeface="Arial"/>
               </a:rPr>
-              <a:t>Error analysis by inspection type, component, period</a:t>
+              <a:t>Compared models and update policies to identify the best-performing one</a:t>
             </a:r>
           </a:p>
           <a:p>
@@ -7979,7 +7979,7 @@
                 </a:solidFill>
                 <a:latin typeface="Arial"/>
               </a:rPr>
-              <a:t>Replay demo, video and report</a:t>
+              <a:t>Error analysis; replay demo, video and report</a:t>
             </a:r>
           </a:p>
         </p:txBody>
@@ -9911,7 +9911,7 @@
                 </a:solidFill>
                 <a:latin typeface="Arial"/>
               </a:rPr>
-              <a:t>1 · Software: the AI decision gate</a:t>
+              <a:t>1 · Successfully trained AI decision gate (software)</a:t>
             </a:r>
           </a:p>
         </p:txBody>
@@ -10035,7 +10035,7 @@
                 </a:solidFill>
                 <a:latin typeface="Arial"/>
               </a:rPr>
-              <a:t>2 · Replay dashboard (demo)</a:t>
+              <a:t>2 · Functional line simulation with decision routing</a:t>
             </a:r>
           </a:p>
         </p:txBody>
@@ -10356,7 +10356,7 @@
                 </a:solidFill>
                 <a:latin typeface="Arial"/>
               </a:rPr>
-              <a:t>3 · Evidence and documents</a:t>
+              <a:t>3 · Comparative performance metrics</a:t>
             </a:r>
           </a:p>
         </p:txBody>
@@ -10395,7 +10395,7 @@
                 </a:solidFill>
                 <a:latin typeface="Arial"/>
               </a:rPr>
-              <a:t>Result files for every number · tests on every push · demo video · final report · public GitHub repository</a:t>
+              <a:t>Trees vs. neural network, update policies; identification of the most efficient model · result files, tests, demo video, report</a:t>
             </a:r>
           </a:p>
         </p:txBody>
@@ -13381,7 +13381,7 @@
                 </a:solidFill>
                 <a:latin typeface="Arial"/>
               </a:rPr>
-              <a:t>✓ Software and simulation only: no machinery, no physical risk</a:t>
+              <a:t>✓ Simulation-only environment; no physical machinery risk</a:t>
             </a:r>
           </a:p>
           <a:p>
@@ -13397,7 +13397,7 @@
                 </a:solidFill>
                 <a:latin typeface="Arial"/>
               </a:rPr>
-              <a:t>✓ Data anonymised by Siemens; no personal data</a:t>
+              <a:t>✓ Dataset is anonymized by Siemens (no personal data)</a:t>
             </a:r>
           </a:p>
           <a:p>
@@ -13429,39 +13429,39 @@
                 </a:solidFill>
                 <a:latin typeface="Arial"/>
               </a:rPr>
+              <a:t>✓ Ethical AI principles followed: transparency, fairness, accountability</a:t>
+            </a:r>
+          </a:p>
+          <a:p>
+            <a:pPr>
+              <a:spcAft>
+                <a:spcPts val="400"/>
+              </a:spcAft>
+            </a:pPr>
+            <a:r>
+              <a:rPr sz="1200" b="0">
+                <a:solidFill>
+                  <a:srgbClr val="14213D"/>
+                </a:solidFill>
+                <a:latin typeface="Arial"/>
+              </a:rPr>
+              <a:t>✓ Avoid dataset bias (strict time split) and ensure reproducibility of results</a:t>
+            </a:r>
+          </a:p>
+          <a:p>
+            <a:pPr>
+              <a:spcAft>
+                <a:spcPts val="400"/>
+              </a:spcAft>
+            </a:pPr>
+            <a:r>
+              <a:rPr sz="1200" b="0">
+                <a:solidFill>
+                  <a:srgbClr val="14213D"/>
+                </a:solidFill>
+                <a:latin typeface="Arial"/>
+              </a:rPr>
               <a:t>✓ Safety first in the design: limit on released defects</a:t>
-            </a:r>
-          </a:p>
-          <a:p>
-            <a:pPr>
-              <a:spcAft>
-                <a:spcPts val="400"/>
-              </a:spcAft>
-            </a:pPr>
-            <a:r>
-              <a:rPr sz="1200" b="0">
-                <a:solidFill>
-                  <a:srgbClr val="14213D"/>
-                </a:solidFill>
-                <a:latin typeface="Arial"/>
-              </a:rPr>
-              <a:t>✓ Transparent: every number from a result file; code public</a:t>
-            </a:r>
-          </a:p>
-          <a:p>
-            <a:pPr>
-              <a:spcAft>
-                <a:spcPts val="400"/>
-              </a:spcAft>
-            </a:pPr>
-            <a:r>
-              <a:rPr sz="1200" b="0">
-                <a:solidFill>
-                  <a:srgbClr val="14213D"/>
-                </a:solidFill>
-                <a:latin typeface="Arial"/>
-              </a:rPr>
-              <a:t>✓ Reproducible: fixed seeds, tests on every push; all sources cited</a:t>
             </a:r>
           </a:p>
         </p:txBody>
@@ -15082,7 +15082,7 @@
                 </a:solidFill>
                 <a:latin typeface="Arial"/>
               </a:rPr>
-              <a:t>THE INDUSTRIAL PROBLEM</a:t>
+              <a:t>INTRODUCTION AND KEY MOTIVATIONS</a:t>
             </a:r>
           </a:p>
         </p:txBody>
@@ -15121,7 +15121,7 @@
                 </a:solidFill>
                 <a:latin typeface="Arial"/>
               </a:rPr>
-              <a:t>Too many false alarms after optical inspection, today</a:t>
+              <a:t>Automated inspection in electronics assembly: too many false alarms, today</a:t>
             </a:r>
           </a:p>
         </p:txBody>
@@ -16012,7 +16012,7 @@
                 </a:solidFill>
                 <a:latin typeface="Arial"/>
               </a:rPr>
-              <a:t>Build and test an AI decision gate that releases AOI false calls on a real Siemens line, while at most 1 % of defective boards are released, also when the line changes over time.</a:t>
+              <a:t>This project aims to explore how an AI-powered decision gate can be integrated after automated optical inspection to release false calls on a real Siemens line, while at most 1 % of defective boards are released.</a:t>
             </a:r>
           </a:p>
         </p:txBody>
@@ -16136,7 +16136,7 @@
                 </a:solidFill>
                 <a:latin typeface="Arial"/>
               </a:rPr>
-              <a:t>Siemens AOI data (132 days, one line)</a:t>
+              <a:t>Data preprocessing: Siemens AOI data, 132 days</a:t>
             </a:r>
           </a:p>
           <a:p>
@@ -16152,7 +16152,7 @@
                 </a:solidFill>
                 <a:latin typeface="Arial"/>
               </a:rPr>
-              <a:t>Decision gate: trees vs. neural network</a:t>
+              <a:t>Training gradient-boosted trees and a neural network</a:t>
             </a:r>
           </a:p>
           <a:p>
@@ -16168,7 +16168,7 @@
                 </a:solidFill>
                 <a:latin typeface="Arial"/>
               </a:rPr>
-              <a:t>Replay simulation of the line in time order</a:t>
+              <a:t>Integration with a simulation of the line (day by day)</a:t>
             </a:r>
           </a:p>
           <a:p>
@@ -16184,7 +16184,7 @@
                 </a:solidFill>
                 <a:latin typeface="Arial"/>
               </a:rPr>
-              <a:t>Drift alarm and update policies</a:t>
+              <a:t>Decision logic: release or manual inspection</a:t>
             </a:r>
           </a:p>
           <a:p>
@@ -16200,7 +16200,7 @@
                 </a:solidFill>
                 <a:latin typeface="Arial"/>
               </a:rPr>
-              <a:t>Error analysis, replay demo</a:t>
+              <a:t>Model performance evaluation using standard metrics</a:t>
             </a:r>
           </a:p>
         </p:txBody>
@@ -16324,6 +16324,38 @@
                 </a:solidFill>
                 <a:latin typeface="Arial"/>
               </a:rPr>
+              <a:t>Real hardware deployment on a line</a:t>
+            </a:r>
+          </a:p>
+          <a:p>
+            <a:pPr>
+              <a:spcAft>
+                <a:spcPts val="400"/>
+              </a:spcAft>
+            </a:pPr>
+            <a:r>
+              <a:rPr sz="1300" b="0">
+                <a:solidFill>
+                  <a:srgbClr val="14213D"/>
+                </a:solidFill>
+                <a:latin typeface="Arial"/>
+              </a:rPr>
+              <a:t>Integration with physical AOI machines or MES</a:t>
+            </a:r>
+          </a:p>
+          <a:p>
+            <a:pPr>
+              <a:spcAft>
+                <a:spcPts val="400"/>
+              </a:spcAft>
+            </a:pPr>
+            <a:r>
+              <a:rPr sz="1300" b="0">
+                <a:solidFill>
+                  <a:srgbClr val="14213D"/>
+                </a:solidFill>
+                <a:latin typeface="Arial"/>
+              </a:rPr>
               <a:t>Changing the AOI machine or its camera images</a:t>
             </a:r>
           </a:p>
@@ -16340,39 +16372,7 @@
                 </a:solidFill>
                 <a:latin typeface="Arial"/>
               </a:rPr>
-              <a:t>Other lines, plants or companies’ own data</a:t>
-            </a:r>
-          </a:p>
-          <a:p>
-            <a:pPr>
-              <a:spcAft>
-                <a:spcPts val="400"/>
-              </a:spcAft>
-            </a:pPr>
-            <a:r>
-              <a:rPr sz="1300" b="0">
-                <a:solidFill>
-                  <a:srgbClr val="14213D"/>
-                </a:solidFill>
-                <a:latin typeface="Arial"/>
-              </a:rPr>
-              <a:t>Running the gate on a real line</a:t>
-            </a:r>
-          </a:p>
-          <a:p>
-            <a:pPr>
-              <a:spcAft>
-                <a:spcPts val="400"/>
-              </a:spcAft>
-            </a:pPr>
-            <a:r>
-              <a:rPr sz="1300" b="0">
-                <a:solidFill>
-                  <a:srgbClr val="14213D"/>
-                </a:solidFill>
-                <a:latin typeface="Arial"/>
-              </a:rPr>
-              <a:t>Root-cause analysis of solder defects</a:t>
+              <a:t>Other lines or plants; root causes of defects</a:t>
             </a:r>
           </a:p>
         </p:txBody>
@@ -17397,7 +17397,7 @@
                 </a:solidFill>
                 <a:latin typeface="Arial"/>
               </a:rPr>
-              <a:t>Build an AI decision gate that decides per flagged board: release or manual inspection.</a:t>
+              <a:t>Train gradient-boosted trees and a neural network to decide per flagged board: real defect or false call.</a:t>
             </a:r>
           </a:p>
         </p:txBody>
@@ -17521,7 +17521,7 @@
                 </a:solidFill>
                 <a:latin typeface="Arial"/>
               </a:rPr>
-              <a:t>Build a replay simulation that plays the Siemens line back day by day in time order.</a:t>
+              <a:t>Integrate the trained models into a day-by-day simulation of the Siemens line.</a:t>
             </a:r>
           </a:p>
         </p:txBody>
@@ -17645,7 +17645,7 @@
                 </a:solidFill>
                 <a:latin typeface="Arial"/>
               </a:rPr>
-              <a:t>Compare gradient-boosted trees with a neural network, and compare model update policies.</a:t>
+              <a:t>Compare performance to identify the most efficient model and update policy for future deployment.</a:t>
             </a:r>
           </a:p>
         </p:txBody>
@@ -17893,7 +17893,7 @@
                 </a:solidFill>
                 <a:latin typeface="Arial"/>
               </a:rPr>
-              <a:t>Evaluate with production KPIs: defective boards released, manual inspections saved, time per board.</a:t>
+              <a:t>Evaluate models based on precision, recall, defective boards released and manual inspections saved.</a:t>
             </a:r>
           </a:p>
         </p:txBody>

</xml_diff>

<commit_message>
Standard terms: binary classification of AOI alarms (true defect or false call)
</commit_message>
<xml_diff>
--- a/docs/slides_revised_topic.pptx
+++ b/docs/slides_revised_topic.pptx
@@ -4393,7 +4393,7 @@
                 </a:solidFill>
                 <a:latin typeface="Arial"/>
               </a:rPr>
-              <a:t>Successfully trained AI decision gate (Python software prototype)</a:t>
+              <a:t>Successfully trained binary classifier for AOI alarms (Python software prototype)</a:t>
             </a:r>
           </a:p>
         </p:txBody>
@@ -5715,7 +5715,7 @@
                 </a:solidFill>
                 <a:latin typeface="Arial"/>
               </a:rPr>
-              <a:t>Safety first in the design: limit on released defective boards</a:t>
+              <a:t>Safety first in the design: limit on missed defects (≤ 1 %)</a:t>
             </a:r>
           </a:p>
         </p:txBody>
@@ -6379,7 +6379,7 @@
                 </a:solidFill>
                 <a:latin typeface="Arial"/>
               </a:rPr>
-              <a:t>The gate runs next to the operators and only logs its decisions.</a:t>
+              <a:t>The classifier runs next to the operators and only logs its results.</a:t>
             </a:r>
           </a:p>
         </p:txBody>
@@ -6546,7 +6546,7 @@
                 </a:solidFill>
                 <a:latin typeface="Arial"/>
               </a:rPr>
-              <a:t>Quality engineers compare the logs before any board is released.</a:t>
+              <a:t>Quality engineers compare the logs before any board skips manual inspection.</a:t>
             </a:r>
           </a:p>
         </p:txBody>
@@ -8001,7 +8001,7 @@
                 </a:solidFill>
                 <a:latin typeface="Arial"/>
               </a:rPr>
-              <a:t>Fewer false calls sent to manual inspection, without releasing defective boards.</a:t>
+              <a:t>Classify each AOI alarm as true defect or false call: fewer false calls to manual inspection, no extra defects missed.</a:t>
             </a:r>
           </a:p>
         </p:txBody>
@@ -8066,7 +8066,7 @@
                 </a:solidFill>
                 <a:latin typeface="Arial"/>
               </a:rPr>
-              <a:t>ONE GOAL: FEWER FALSE CALLS, WITHOUT RELEASING DEFECTS</a:t>
+              <a:t>ONE GOAL: FEWER FALSE CALLS, WITHOUT MISSING DEFECTS</a:t>
             </a:r>
           </a:p>
         </p:txBody>
@@ -8331,7 +8331,7 @@
                 </a:solidFill>
                 <a:latin typeface="Arial"/>
               </a:rPr>
-              <a:t>AOI data of a flagged board</a:t>
+              <a:t>AOI alarm</a:t>
             </a:r>
           </a:p>
         </p:txBody>
@@ -8370,7 +8370,7 @@
                 </a:solidFill>
                 <a:latin typeface="Arial"/>
               </a:rPr>
-              <a:t>about 70 measurements per solder joint</a:t>
+              <a:t>flagged board: about 70 measurements per solder joint</a:t>
             </a:r>
           </a:p>
           <a:p>
@@ -8553,7 +8553,7 @@
                 </a:solidFill>
                 <a:latin typeface="Arial"/>
               </a:rPr>
-              <a:t>AI decision gate</a:t>
+              <a:t>Binary classification</a:t>
             </a:r>
           </a:p>
         </p:txBody>
@@ -8592,7 +8592,7 @@
                 </a:solidFill>
                 <a:latin typeface="Arial"/>
               </a:rPr>
-              <a:t>classifier trained on past manual-inspection results</a:t>
+              <a:t>supervised machine learning, trained on past manual-inspection results</a:t>
             </a:r>
           </a:p>
           <a:p>
@@ -8608,7 +8608,7 @@
                 </a:solidFill>
                 <a:latin typeface="Arial"/>
               </a:rPr>
-              <a:t>threshold: ≤ 1 % defective boards released</a:t>
+              <a:t>threshold: ≤ 1 % of defects missed</a:t>
             </a:r>
           </a:p>
         </p:txBody>
@@ -8690,7 +8690,7 @@
                 </a:solidFill>
                 <a:latin typeface="Arial"/>
               </a:rPr>
-              <a:t>OUTPUT</a:t>
+              <a:t>OUTPUT: IS THE AOI ALARM REAL?</a:t>
             </a:r>
           </a:p>
         </p:txBody>
@@ -8775,7 +8775,7 @@
                 </a:solidFill>
                 <a:latin typeface="Arial"/>
               </a:rPr>
-              <a:t>Release</a:t>
+              <a:t>False call</a:t>
             </a:r>
           </a:p>
           <a:p>
@@ -8791,7 +8791,7 @@
                 </a:solidFill>
                 <a:latin typeface="Arial"/>
               </a:rPr>
-              <a:t>likely false call → next step</a:t>
+              <a:t>→ skip manual inspection</a:t>
             </a:r>
           </a:p>
         </p:txBody>
@@ -8876,7 +8876,7 @@
                 </a:solidFill>
                 <a:latin typeface="Arial"/>
               </a:rPr>
-              <a:t>Manual inspection</a:t>
+              <a:t>True defect</a:t>
             </a:r>
           </a:p>
           <a:p>
@@ -8892,7 +8892,7 @@
                 </a:solidFill>
                 <a:latin typeface="Arial"/>
               </a:rPr>
-              <a:t>possible defect → operator checks</a:t>
+              <a:t>→ manual inspection, repair</a:t>
             </a:r>
           </a:p>
         </p:txBody>
@@ -9179,7 +9179,7 @@
                 </a:solidFill>
                 <a:latin typeface="Arial"/>
               </a:rPr>
-              <a:t>a released defective board reaches the customer</a:t>
+              <a:t>a missed defective board reaches the customer</a:t>
             </a:r>
           </a:p>
         </p:txBody>
@@ -9633,7 +9633,7 @@
                 </a:solidFill>
                 <a:latin typeface="Arial"/>
               </a:rPr>
-              <a:t>This project aims to reduce false calls after automated optical inspection with an AI decision gate, while at most 1 % of defective boards are released.</a:t>
+              <a:t>This project aims to reduce false calls after automated optical inspection: a binary classifier decides for each AOI alarm whether it is a true defect or a false call, while at most 1 % of defects are missed.</a:t>
             </a:r>
           </a:p>
         </p:txBody>
@@ -10463,7 +10463,7 @@
                 </a:solidFill>
                 <a:latin typeface="Arial"/>
               </a:rPr>
-              <a:t>Reduce false calls: train three models to separate false calls from real defects.</a:t>
+              <a:t>Reduce false calls: train three classifiers to separate false calls from true defects.</a:t>
             </a:r>
           </a:p>
         </p:txBody>
@@ -10587,7 +10587,7 @@
                 </a:solidFill>
                 <a:latin typeface="Arial"/>
               </a:rPr>
-              <a:t>Keep quality: set a threshold so that at most 1 % of defective boards are released.</a:t>
+              <a:t>Keep quality: set the classification threshold so that at most 1 % of defective boards are missed.</a:t>
             </a:r>
           </a:p>
         </p:txBody>
@@ -10998,7 +10998,7 @@
                 </a:solidFill>
                 <a:latin typeface="Arial"/>
               </a:rPr>
-              <a:t>false-call boards released, i.e. manual inspections saved (baseline 6.4 %)</a:t>
+              <a:t>false calls correctly identified, i.e. manual inspections saved (baseline 6.4 %)</a:t>
             </a:r>
           </a:p>
         </p:txBody>
@@ -11076,7 +11076,7 @@
                 </a:solidFill>
                 <a:latin typeface="Arial"/>
               </a:rPr>
-              <a:t>defective boards released</a:t>
+              <a:t>defective boards missed (classified as false call)</a:t>
             </a:r>
           </a:p>
         </p:txBody>
@@ -11639,7 +11639,7 @@
                           </a:solidFill>
                           <a:latin typeface="Arial"/>
                         </a:rPr>
-                        <a:t>Precision, recall, confusion matrix, boards released</a:t>
+                        <a:t>Precision, recall, confusion matrix, missed defects</a:t>
                       </a:r>
                     </a:p>
                   </a:txBody>
@@ -12577,7 +12577,7 @@
                 </a:solidFill>
                 <a:latin typeface="Arial"/>
               </a:rPr>
-              <a:t>Release threshold</a:t>
+              <a:t>Classification threshold</a:t>
             </a:r>
           </a:p>
         </p:txBody>
@@ -12616,7 +12616,7 @@
                 </a:solidFill>
                 <a:latin typeface="Arial"/>
               </a:rPr>
-              <a:t>≤ 1 % defects released</a:t>
+              <a:t>≤ 1 % defects missed</a:t>
             </a:r>
           </a:p>
         </p:txBody>
@@ -13841,7 +13841,7 @@
                 </a:solidFill>
                 <a:latin typeface="Arial"/>
               </a:rPr>
-              <a:t>Set the threshold: ≤ 1 % defective boards released</a:t>
+              <a:t>Set the classification threshold: ≤ 1 % of defects missed</a:t>
             </a:r>
           </a:p>
         </p:txBody>
@@ -14121,7 +14121,7 @@
                 </a:solidFill>
                 <a:latin typeface="Arial"/>
               </a:rPr>
-              <a:t>Analyzed precision, recall, defects released, inspections saved</a:t>
+              <a:t>Analyzed precision, recall, missed defects, inspections saved</a:t>
             </a:r>
           </a:p>
           <a:p>
@@ -14507,7 +14507,7 @@
                 </a:solidFill>
                 <a:latin typeface="Arial"/>
               </a:rPr>
-              <a:t>Today: 6–15 % of false-call boards released (manual inspections saved).</a:t>
+              <a:t>Today: 6–15 % of false calls correctly identified (manual inspections saved).</a:t>
             </a:r>
           </a:p>
           <a:p>
@@ -14523,7 +14523,7 @@
                 </a:solidFill>
                 <a:latin typeface="Arial"/>
               </a:rPr>
-              <a:t>But 2.2–3.7 % of defective boards slip through: above the 1 % limit.</a:t>
+              <a:t>But 2.2–3.7 % of defective boards are missed: above the 1 % limit.</a:t>
             </a:r>
           </a:p>
           <a:p>
@@ -14539,7 +14539,7 @@
                 </a:solidFill>
                 <a:latin typeface="Arial"/>
               </a:rPr>
-              <a:t>Next: ≥ 20 % released at ≤ 1 % defects.</a:t>
+              <a:t>Next: ≥ 20 % identified at ≤ 1 % missed.</a:t>
             </a:r>
           </a:p>
         </p:txBody>

</xml_diff>

<commit_message>
Title: Second Check of AOI Results with Supervised Machine Learning
</commit_message>
<xml_diff>
--- a/docs/slides_revised_topic.pptx
+++ b/docs/slides_revised_topic.pptx
@@ -3223,7 +3223,7 @@
                 </a:solidFill>
                 <a:latin typeface="Arial"/>
               </a:rPr>
-              <a:t>AI-powered Quality Control and Defect Detection in Electronics Assembly</a:t>
+              <a:t>Second Check of AOI Results with Supervised Machine Learning</a:t>
             </a:r>
           </a:p>
         </p:txBody>
@@ -3262,7 +3262,7 @@
                 </a:solidFill>
                 <a:latin typeface="Arial"/>
               </a:rPr>
-              <a:t>Reducing false calls of automated optical inspection (AOI) with Siemens production data</a:t>
+              <a:t>Quality control and defect detection in electronics assembly: binary classification of AOI alarms into true defects and false calls (Siemens production data)</a:t>
             </a:r>
           </a:p>
         </p:txBody>
@@ -3507,7 +3507,7 @@
                 </a:solidFill>
                 <a:latin typeface="Arial"/>
               </a:rPr>
-              <a:t>AI-powered Quality Control and Defect Detection · Team 1</a:t>
+              <a:t>Second Check of AOI Results with Supervised Machine Learning · Team 1</a:t>
             </a:r>
           </a:p>
         </p:txBody>
@@ -4230,7 +4230,7 @@
                 </a:solidFill>
                 <a:latin typeface="Arial"/>
               </a:rPr>
-              <a:t>AI-powered Quality Control and Defect Detection · Team 1</a:t>
+              <a:t>Second Check of AOI Results with Supervised Machine Learning · Team 1</a:t>
             </a:r>
           </a:p>
         </p:txBody>
@@ -5056,7 +5056,7 @@
                 </a:solidFill>
                 <a:latin typeface="Arial"/>
               </a:rPr>
-              <a:t>AI-powered Quality Control and Defect Detection · Team 1</a:t>
+              <a:t>Second Check of AOI Results with Supervised Machine Learning · Team 1</a:t>
             </a:r>
           </a:p>
         </p:txBody>
@@ -5467,7 +5467,7 @@
                 </a:solidFill>
                 <a:latin typeface="Arial"/>
               </a:rPr>
-              <a:t>Ethical AI principles followed: transparency, fairness, accountability</a:t>
+              <a:t>Ethical principles followed: transparency, fairness, accountability</a:t>
             </a:r>
           </a:p>
         </p:txBody>
@@ -5882,7 +5882,7 @@
                 </a:solidFill>
                 <a:latin typeface="Arial"/>
               </a:rPr>
-              <a:t>AI-powered Quality Control and Defect Detection · Team 1</a:t>
+              <a:t>Second Check of AOI Results with Supervised Machine Learning · Team 1</a:t>
             </a:r>
           </a:p>
         </p:txBody>
@@ -6713,7 +6713,7 @@
                 </a:solidFill>
                 <a:latin typeface="Arial"/>
               </a:rPr>
-              <a:t>AI-powered Quality Control and Defect Detection · Team 1</a:t>
+              <a:t>Second Check of AOI Results with Supervised Machine Learning · Team 1</a:t>
             </a:r>
           </a:p>
         </p:txBody>
@@ -7038,7 +7038,7 @@
                 </a:solidFill>
                 <a:latin typeface="Arial"/>
               </a:rPr>
-              <a:t>AI-powered Quality Control and Defect Detection · Team 1</a:t>
+              <a:t>Second Check of AOI Results with Supervised Machine Learning · Team 1</a:t>
             </a:r>
           </a:p>
         </p:txBody>
@@ -7450,7 +7450,7 @@
                 </a:solidFill>
                 <a:latin typeface="Arial"/>
               </a:rPr>
-              <a:t>AI-powered Quality Control and Defect Detection · Team 1</a:t>
+              <a:t>Second Check of AOI Results with Supervised Machine Learning · Team 1</a:t>
             </a:r>
           </a:p>
         </p:txBody>
@@ -7877,7 +7877,7 @@
                 </a:solidFill>
                 <a:latin typeface="Arial"/>
               </a:rPr>
-              <a:t>AI second check of AOI results: real defect or false call? Target: about 40 % fewer false calls.</a:t>
+              <a:t>“AI second check of AOI results”: real defect or false call? Target: about 40 % fewer false calls.</a:t>
             </a:r>
           </a:p>
         </p:txBody>
@@ -8168,7 +8168,7 @@
                 </a:solidFill>
                 <a:latin typeface="Arial"/>
               </a:rPr>
-              <a:t>AI-powered Quality Control and Defect Detection · Team 1</a:t>
+              <a:t>Second Check of AOI Results with Supervised Machine Learning · Team 1</a:t>
             </a:r>
           </a:p>
         </p:txBody>
@@ -9470,7 +9470,7 @@
                 </a:solidFill>
                 <a:latin typeface="Arial"/>
               </a:rPr>
-              <a:t>AI-powered Quality Control and Defect Detection · Team 1</a:t>
+              <a:t>Second Check of AOI Results with Supervised Machine Learning · Team 1</a:t>
             </a:r>
           </a:p>
         </p:txBody>
@@ -10300,7 +10300,7 @@
                 </a:solidFill>
                 <a:latin typeface="Arial"/>
               </a:rPr>
-              <a:t>AI-powered Quality Control and Defect Detection · Team 1</a:t>
+              <a:t>Second Check of AOI Results with Supervised Machine Learning · Team 1</a:t>
             </a:r>
           </a:p>
         </p:txBody>
@@ -11243,7 +11243,7 @@
                 </a:solidFill>
                 <a:latin typeface="Arial"/>
               </a:rPr>
-              <a:t>AI-powered Quality Control and Defect Detection · Team 1</a:t>
+              <a:t>Second Check of AOI Results with Supervised Machine Learning · Team 1</a:t>
             </a:r>
           </a:p>
         </p:txBody>
@@ -11952,7 +11952,7 @@
                 </a:solidFill>
                 <a:latin typeface="Arial"/>
               </a:rPr>
-              <a:t>AI-powered Quality Control and Defect Detection · Team 1</a:t>
+              <a:t>Second Check of AOI Results with Supervised Machine Learning · Team 1</a:t>
             </a:r>
           </a:p>
         </p:txBody>
@@ -13490,7 +13490,7 @@
                 </a:solidFill>
                 <a:latin typeface="Arial"/>
               </a:rPr>
-              <a:t>AI-powered Quality Control and Defect Detection · Team 1</a:t>
+              <a:t>Second Check of AOI Results with Supervised Machine Learning · Team 1</a:t>
             </a:r>
           </a:p>
         </p:txBody>
@@ -14320,7 +14320,7 @@
                 </a:solidFill>
                 <a:latin typeface="Arial"/>
               </a:rPr>
-              <a:t>AI-powered Quality Control and Defect Detection · Team 1</a:t>
+              <a:t>Second Check of AOI Results with Supervised Machine Learning · Team 1</a:t>
             </a:r>
           </a:p>
         </p:txBody>

</xml_diff>

<commit_message>
Precise scope and metrics: recall and specificity of the binary classification
</commit_message>
<xml_diff>
--- a/docs/slides_revised_topic.pptx
+++ b/docs/slides_revised_topic.pptx
@@ -4517,7 +4517,7 @@
                 </a:solidFill>
                 <a:latin typeface="Arial"/>
               </a:rPr>
-              <a:t>Functional day-by-day simulation of the line with decision routing</a:t>
+              <a:t>Day-by-day simulation on the recorded data, with recall and specificity</a:t>
             </a:r>
           </a:p>
         </p:txBody>
@@ -4641,7 +4641,7 @@
                 </a:solidFill>
                 <a:latin typeface="Arial"/>
               </a:rPr>
-              <a:t>Comparative performance metrics for the three models</a:t>
+              <a:t>Comparative performance metrics for the three classifiers</a:t>
             </a:r>
           </a:p>
         </p:txBody>
@@ -5715,7 +5715,7 @@
                 </a:solidFill>
                 <a:latin typeface="Arial"/>
               </a:rPr>
-              <a:t>Safety first in the design: limit on missed defects (≤ 1 %)</a:t>
+              <a:t>Safety first in the design: recall of true defects ≥ 99 %</a:t>
             </a:r>
           </a:p>
         </p:txBody>
@@ -6212,7 +6212,7 @@
                 </a:solidFill>
                 <a:latin typeface="Arial"/>
               </a:rPr>
-              <a:t>Read each board’s AOI result from the machine; send the decision to the repair station.</a:t>
+              <a:t>Read each board’s AOI result from the machine; send the classification to the manual inspection station.</a:t>
             </a:r>
           </a:p>
         </p:txBody>
@@ -7753,7 +7753,7 @@
                 </a:solidFill>
                 <a:latin typeface="Arial"/>
               </a:rPr>
-              <a:t>“Siemens – Quality Control and Defect Detection”. Key motivations: reduce dependence on manual quality checks, keep product quality, increase efficiency.</a:t>
+              <a:t>“Siemens – Quality Control and Defect Detection”. Key motivation: fewer manual re-inspections of false calls, while true defects are still caught.</a:t>
             </a:r>
           </a:p>
         </p:txBody>
@@ -8001,7 +8001,7 @@
                 </a:solidFill>
                 <a:latin typeface="Arial"/>
               </a:rPr>
-              <a:t>Classify each AOI alarm as true defect or false call: fewer false calls to manual inspection, no extra defects missed.</a:t>
+              <a:t>Classify each AOI alarm as true defect or false call, so that fewer false calls go to manual inspection while at most 1 % of true defects are missed.</a:t>
             </a:r>
           </a:p>
         </p:txBody>
@@ -8066,7 +8066,7 @@
                 </a:solidFill>
                 <a:latin typeface="Arial"/>
               </a:rPr>
-              <a:t>ONE GOAL: FEWER FALSE CALLS, WITHOUT MISSING DEFECTS</a:t>
+              <a:t>ONE GOAL: FEWER FALSE CALLS TO MANUAL INSPECTION, AT MOST 1 % OF TRUE DEFECTS MISSED</a:t>
             </a:r>
           </a:p>
         </p:txBody>
@@ -8370,7 +8370,7 @@
                 </a:solidFill>
                 <a:latin typeface="Arial"/>
               </a:rPr>
-              <a:t>flagged board: about 70 measurements per solder joint</a:t>
+              <a:t>one flagged board: about 70 AOI measurements per flagged solder joint</a:t>
             </a:r>
           </a:p>
           <a:p>
@@ -8608,7 +8608,7 @@
                 </a:solidFill>
                 <a:latin typeface="Arial"/>
               </a:rPr>
-              <a:t>threshold: ≤ 1 % of defects missed</a:t>
+              <a:t>classification threshold: recall ≥ 99 %</a:t>
             </a:r>
           </a:p>
         </p:txBody>
@@ -9633,7 +9633,7 @@
                 </a:solidFill>
                 <a:latin typeface="Arial"/>
               </a:rPr>
-              <a:t>This project aims to reduce false calls after automated optical inspection: a binary classifier decides for each AOI alarm whether it is a true defect or a false call, while at most 1 % of defects are missed.</a:t>
+              <a:t>This project aims to reduce false calls after automated optical inspection: a binary classifier decides for each AOI alarm whether it is a true defect or a false call, while at most 1 % of true defects are missed.</a:t>
             </a:r>
           </a:p>
         </p:txBody>
@@ -9773,7 +9773,7 @@
                 </a:solidFill>
                 <a:latin typeface="Arial"/>
               </a:rPr>
-              <a:t>Training three models</a:t>
+              <a:t>Training three classifiers</a:t>
             </a:r>
           </a:p>
           <a:p>
@@ -9789,7 +9789,7 @@
                 </a:solidFill>
                 <a:latin typeface="Arial"/>
               </a:rPr>
-              <a:t>Day-by-day simulation of the line</a:t>
+              <a:t>Day-by-day simulation on recorded data</a:t>
             </a:r>
           </a:p>
           <a:p>
@@ -9805,7 +9805,7 @@
                 </a:solidFill>
                 <a:latin typeface="Arial"/>
               </a:rPr>
-              <a:t>Evaluation using standard metrics</a:t>
+              <a:t>Evaluation: recall, specificity, confusion matrix</a:t>
             </a:r>
           </a:p>
         </p:txBody>
@@ -9961,7 +9961,7 @@
                 </a:solidFill>
                 <a:latin typeface="Arial"/>
               </a:rPr>
-              <a:t>Changing the AOI camera images</a:t>
+              <a:t>Changing the AOI inspection itself (camera, limits)</a:t>
             </a:r>
           </a:p>
         </p:txBody>
@@ -10587,7 +10587,7 @@
                 </a:solidFill>
                 <a:latin typeface="Arial"/>
               </a:rPr>
-              <a:t>Keep quality: set the classification threshold so that at most 1 % of defective boards are missed.</a:t>
+              <a:t>Keep quality: set the classification threshold so that recall of true defects is at least 99 %.</a:t>
             </a:r>
           </a:p>
         </p:txBody>
@@ -10711,7 +10711,7 @@
                 </a:solidFill>
                 <a:latin typeface="Arial"/>
               </a:rPr>
-              <a:t>Test on the line: integrate the models into a day-by-day simulation of the Siemens line.</a:t>
+              <a:t>Test as in operation: day-by-day simulation on the recorded Siemens data, models trained on earlier days only.</a:t>
             </a:r>
           </a:p>
         </p:txBody>
@@ -10914,13 +10914,13 @@
               </a:spcAft>
             </a:pPr>
             <a:r>
-              <a:rPr sz="1500" b="1">
+              <a:rPr sz="1300" b="1">
                 <a:solidFill>
                   <a:srgbClr val="2F6DB5"/>
                 </a:solidFill>
                 <a:latin typeface="Arial"/>
               </a:rPr>
-              <a:t>Requirements (two KPIs)</a:t>
+              <a:t>Requirements (positive class = true defect)</a:t>
             </a:r>
           </a:p>
         </p:txBody>
@@ -10959,7 +10959,7 @@
                 </a:solidFill>
                 <a:latin typeface="Arial"/>
               </a:rPr>
-              <a:t>≥ 20 %</a:t>
+              <a:t>≥ 99 %</a:t>
             </a:r>
           </a:p>
         </p:txBody>
@@ -10998,7 +10998,7 @@
                 </a:solidFill>
                 <a:latin typeface="Arial"/>
               </a:rPr>
-              <a:t>false calls correctly identified, i.e. manual inspections saved (baseline 6.4 %)</a:t>
+              <a:t>recall: true defects classified as true defect (≤ 1 % missed)</a:t>
             </a:r>
           </a:p>
         </p:txBody>
@@ -11037,7 +11037,7 @@
                 </a:solidFill>
                 <a:latin typeface="Arial"/>
               </a:rPr>
-              <a:t>≤ 1 %</a:t>
+              <a:t>≥ 20 %</a:t>
             </a:r>
           </a:p>
         </p:txBody>
@@ -11076,7 +11076,7 @@
                 </a:solidFill>
                 <a:latin typeface="Arial"/>
               </a:rPr>
-              <a:t>defective boards missed (classified as false call)</a:t>
+              <a:t>specificity: false calls classified as false call = manual inspections saved (baseline 6.4 %)</a:t>
             </a:r>
           </a:p>
         </p:txBody>
@@ -11571,7 +11571,7 @@
                           </a:solidFill>
                           <a:latin typeface="Arial"/>
                         </a:rPr>
-                        <a:t>Day-by-day simulation of the line: release or manual inspection</a:t>
+                        <a:t>Day-by-day simulation on recorded production days (walk-forward)</a:t>
                       </a:r>
                     </a:p>
                   </a:txBody>
@@ -11639,7 +11639,7 @@
                           </a:solidFill>
                           <a:latin typeface="Arial"/>
                         </a:rPr>
-                        <a:t>Precision, recall, confusion matrix, missed defects</a:t>
+                        <a:t>Recall, specificity, confusion matrix</a:t>
                       </a:r>
                     </a:p>
                   </a:txBody>
@@ -12577,7 +12577,7 @@
                 </a:solidFill>
                 <a:latin typeface="Arial"/>
               </a:rPr>
-              <a:t>Classification threshold</a:t>
+              <a:t>Threshold</a:t>
             </a:r>
           </a:p>
         </p:txBody>
@@ -12616,7 +12616,7 @@
                 </a:solidFill>
                 <a:latin typeface="Arial"/>
               </a:rPr>
-              <a:t>≤ 1 % defects missed</a:t>
+              <a:t>recall ≥ 99 %</a:t>
             </a:r>
           </a:p>
         </p:txBody>
@@ -12701,7 +12701,7 @@
                 </a:solidFill>
                 <a:latin typeface="Arial"/>
               </a:rPr>
-              <a:t>Simulation of the line</a:t>
+              <a:t>Simulation</a:t>
             </a:r>
           </a:p>
         </p:txBody>
@@ -12740,7 +12740,7 @@
                 </a:solidFill>
                 <a:latin typeface="Arial"/>
               </a:rPr>
-              <a:t>day by day</a:t>
+              <a:t>day by day, recorded data</a:t>
             </a:r>
           </a:p>
         </p:txBody>
@@ -12868,7 +12868,7 @@
                 </a:solidFill>
                 <a:latin typeface="Arial"/>
               </a:rPr>
-              <a:t>Decision routing</a:t>
+              <a:t>Classification result</a:t>
             </a:r>
           </a:p>
         </p:txBody>
@@ -12907,7 +12907,7 @@
                 </a:solidFill>
                 <a:latin typeface="Arial"/>
               </a:rPr>
-              <a:t>release / manual inspection</a:t>
+              <a:t>true defect / false call</a:t>
             </a:r>
           </a:p>
         </p:txBody>
@@ -13074,7 +13074,7 @@
                 </a:solidFill>
                 <a:latin typeface="Arial"/>
               </a:rPr>
-              <a:t>KPIs, comparison</a:t>
+              <a:t>recall, specificity</a:t>
             </a:r>
           </a:p>
         </p:txBody>
@@ -13841,7 +13841,7 @@
                 </a:solidFill>
                 <a:latin typeface="Arial"/>
               </a:rPr>
-              <a:t>Set the classification threshold: ≤ 1 % of defects missed</a:t>
+              <a:t>Set the classification threshold: recall ≥ 99 %</a:t>
             </a:r>
           </a:p>
         </p:txBody>
@@ -13965,7 +13965,7 @@
                 </a:solidFill>
                 <a:latin typeface="Arial"/>
               </a:rPr>
-              <a:t>Simulated the line day by day</a:t>
+              <a:t>Simulated operation day by day on the recorded days</a:t>
             </a:r>
           </a:p>
           <a:p>
@@ -13981,7 +13981,7 @@
                 </a:solidFill>
                 <a:latin typeface="Arial"/>
               </a:rPr>
-              <a:t>Each day decided by a model trained on earlier days only</a:t>
+              <a:t>Each day classified by a model trained on earlier days only</a:t>
             </a:r>
           </a:p>
           <a:p>
@@ -13997,7 +13997,7 @@
                 </a:solidFill>
                 <a:latin typeface="Arial"/>
               </a:rPr>
-              <a:t>Boards are virtually routed to release or manual inspection</a:t>
+              <a:t>Boards classified as false call virtually skip manual inspection</a:t>
             </a:r>
           </a:p>
         </p:txBody>
@@ -14121,7 +14121,7 @@
                 </a:solidFill>
                 <a:latin typeface="Arial"/>
               </a:rPr>
-              <a:t>Analyzed precision, recall, missed defects, inspections saved</a:t>
+              <a:t>Analyzed recall, specificity and the confusion matrix</a:t>
             </a:r>
           </a:p>
           <a:p>
@@ -14257,7 +14257,7 @@
                 </a:solidFill>
                 <a:latin typeface="Arial"/>
               </a:rPr>
-              <a:t>Day-by-day simulation of the line: three models running</a:t>
+              <a:t>Day-by-day simulation on recorded data: three classifiers</a:t>
             </a:r>
           </a:p>
         </p:txBody>
@@ -14507,7 +14507,7 @@
                 </a:solidFill>
                 <a:latin typeface="Arial"/>
               </a:rPr>
-              <a:t>Today: 6–15 % of false calls correctly identified (manual inspections saved).</a:t>
+              <a:t>Specificity today: 6.5–15.0 % (false calls correctly classified).</a:t>
             </a:r>
           </a:p>
           <a:p>
@@ -14523,7 +14523,7 @@
                 </a:solidFill>
                 <a:latin typeface="Arial"/>
               </a:rPr>
-              <a:t>But 2.2–3.7 % of defective boards are missed: above the 1 % limit.</a:t>
+              <a:t>Recall today: 96.3–97.8 % (2.2–3.7 % of true defects missed): below the 99 % requirement.</a:t>
             </a:r>
           </a:p>
           <a:p>
@@ -14539,7 +14539,7 @@
                 </a:solidFill>
                 <a:latin typeface="Arial"/>
               </a:rPr>
-              <a:t>Next: ≥ 20 % identified at ≤ 1 % missed.</a:t>
+              <a:t>Next: recall ≥ 99 % with specificity ≥ 20 %.</a:t>
             </a:r>
           </a:p>
         </p:txBody>

</xml_diff>

<commit_message>
Title: Binary Classification of AOI Alarms into True Defects and False Calls
</commit_message>
<xml_diff>
--- a/docs/slides_revised_topic.pptx
+++ b/docs/slides_revised_topic.pptx
@@ -3223,7 +3223,7 @@
                 </a:solidFill>
                 <a:latin typeface="Arial"/>
               </a:rPr>
-              <a:t>Second Check of AOI Results with Supervised Machine Learning</a:t>
+              <a:t>Binary Classification of AOI Alarms into True Defects and False Calls</a:t>
             </a:r>
           </a:p>
         </p:txBody>
@@ -3262,7 +3262,7 @@
                 </a:solidFill>
                 <a:latin typeface="Arial"/>
               </a:rPr>
-              <a:t>Binary classification of AOI alarms into true defects and false calls (Siemens production data)</a:t>
+              <a:t>Second check of AOI results with supervised machine learning (Siemens production data)</a:t>
             </a:r>
           </a:p>
         </p:txBody>
@@ -3507,7 +3507,7 @@
                 </a:solidFill>
                 <a:latin typeface="Arial"/>
               </a:rPr>
-              <a:t>Second Check of AOI Results with Supervised Machine Learning · Team 1</a:t>
+              <a:t>Binary Classification of AOI Alarms into True Defects and False Calls · Team 1</a:t>
             </a:r>
           </a:p>
         </p:txBody>
@@ -4230,7 +4230,7 @@
                 </a:solidFill>
                 <a:latin typeface="Arial"/>
               </a:rPr>
-              <a:t>Second Check of AOI Results with Supervised Machine Learning · Team 1</a:t>
+              <a:t>Binary Classification of AOI Alarms into True Defects and False Calls · Team 1</a:t>
             </a:r>
           </a:p>
         </p:txBody>
@@ -5056,7 +5056,7 @@
                 </a:solidFill>
                 <a:latin typeface="Arial"/>
               </a:rPr>
-              <a:t>Second Check of AOI Results with Supervised Machine Learning · Team 1</a:t>
+              <a:t>Binary Classification of AOI Alarms into True Defects and False Calls · Team 1</a:t>
             </a:r>
           </a:p>
         </p:txBody>
@@ -5882,7 +5882,7 @@
                 </a:solidFill>
                 <a:latin typeface="Arial"/>
               </a:rPr>
-              <a:t>Second Check of AOI Results with Supervised Machine Learning · Team 1</a:t>
+              <a:t>Binary Classification of AOI Alarms into True Defects and False Calls · Team 1</a:t>
             </a:r>
           </a:p>
         </p:txBody>
@@ -6713,7 +6713,7 @@
                 </a:solidFill>
                 <a:latin typeface="Arial"/>
               </a:rPr>
-              <a:t>Second Check of AOI Results with Supervised Machine Learning · Team 1</a:t>
+              <a:t>Binary Classification of AOI Alarms into True Defects and False Calls · Team 1</a:t>
             </a:r>
           </a:p>
         </p:txBody>
@@ -7038,7 +7038,7 @@
                 </a:solidFill>
                 <a:latin typeface="Arial"/>
               </a:rPr>
-              <a:t>Second Check of AOI Results with Supervised Machine Learning · Team 1</a:t>
+              <a:t>Binary Classification of AOI Alarms into True Defects and False Calls · Team 1</a:t>
             </a:r>
           </a:p>
         </p:txBody>
@@ -7450,7 +7450,7 @@
                 </a:solidFill>
                 <a:latin typeface="Arial"/>
               </a:rPr>
-              <a:t>Second Check of AOI Results with Supervised Machine Learning · Team 1</a:t>
+              <a:t>Binary Classification of AOI Alarms into True Defects and False Calls · Team 1</a:t>
             </a:r>
           </a:p>
         </p:txBody>
@@ -8168,7 +8168,7 @@
                 </a:solidFill>
                 <a:latin typeface="Arial"/>
               </a:rPr>
-              <a:t>Second Check of AOI Results with Supervised Machine Learning · Team 1</a:t>
+              <a:t>Binary Classification of AOI Alarms into True Defects and False Calls · Team 1</a:t>
             </a:r>
           </a:p>
         </p:txBody>
@@ -9470,7 +9470,7 @@
                 </a:solidFill>
                 <a:latin typeface="Arial"/>
               </a:rPr>
-              <a:t>Second Check of AOI Results with Supervised Machine Learning · Team 1</a:t>
+              <a:t>Binary Classification of AOI Alarms into True Defects and False Calls · Team 1</a:t>
             </a:r>
           </a:p>
         </p:txBody>
@@ -10300,7 +10300,7 @@
                 </a:solidFill>
                 <a:latin typeface="Arial"/>
               </a:rPr>
-              <a:t>Second Check of AOI Results with Supervised Machine Learning · Team 1</a:t>
+              <a:t>Binary Classification of AOI Alarms into True Defects and False Calls · Team 1</a:t>
             </a:r>
           </a:p>
         </p:txBody>
@@ -11243,7 +11243,7 @@
                 </a:solidFill>
                 <a:latin typeface="Arial"/>
               </a:rPr>
-              <a:t>Second Check of AOI Results with Supervised Machine Learning · Team 1</a:t>
+              <a:t>Binary Classification of AOI Alarms into True Defects and False Calls · Team 1</a:t>
             </a:r>
           </a:p>
         </p:txBody>
@@ -11952,7 +11952,7 @@
                 </a:solidFill>
                 <a:latin typeface="Arial"/>
               </a:rPr>
-              <a:t>Second Check of AOI Results with Supervised Machine Learning · Team 1</a:t>
+              <a:t>Binary Classification of AOI Alarms into True Defects and False Calls · Team 1</a:t>
             </a:r>
           </a:p>
         </p:txBody>
@@ -13490,7 +13490,7 @@
                 </a:solidFill>
                 <a:latin typeface="Arial"/>
               </a:rPr>
-              <a:t>Second Check of AOI Results with Supervised Machine Learning · Team 1</a:t>
+              <a:t>Binary Classification of AOI Alarms into True Defects and False Calls · Team 1</a:t>
             </a:r>
           </a:p>
         </p:txBody>
@@ -14320,7 +14320,7 @@
                 </a:solidFill>
                 <a:latin typeface="Arial"/>
               </a:rPr>
-              <a:t>Second Check of AOI Results with Supervised Machine Learning · Team 1</a:t>
+              <a:t>Binary Classification of AOI Alarms into True Defects and False Calls · Team 1</a:t>
             </a:r>
           </a:p>
         </p:txBody>

</xml_diff>

<commit_message>
Data source on the introduction slide; three classification models for one binary task
</commit_message>
<xml_diff>
--- a/docs/slides_revised_topic.pptx
+++ b/docs/slides_revised_topic.pptx
@@ -4641,7 +4641,7 @@
                 </a:solidFill>
                 <a:latin typeface="Arial"/>
               </a:rPr>
-              <a:t>Comparative performance metrics for the three classifiers</a:t>
+              <a:t>Comparative performance metrics for the three classification models</a:t>
             </a:r>
           </a:p>
         </p:txBody>
@@ -7548,7 +7548,7 @@
         </p:nvSpPr>
         <p:spPr>
           <a:xfrm>
-            <a:off x="1029599" y="1944000"/>
+            <a:off x="1029599" y="1872000"/>
             <a:ext cx="3024000" cy="1080000"/>
           </a:xfrm>
           <a:prstGeom prst="rect">
@@ -7587,8 +7587,8 @@
         </p:nvSpPr>
         <p:spPr>
           <a:xfrm>
-            <a:off x="1029599" y="3168000"/>
-            <a:ext cx="3024000" cy="2160000"/>
+            <a:off x="1029599" y="3060000"/>
+            <a:ext cx="3024000" cy="1296000"/>
           </a:xfrm>
           <a:prstGeom prst="rect">
             <a:avLst/>
@@ -7607,36 +7607,98 @@
               </a:spcAft>
             </a:pPr>
             <a:r>
+              <a:rPr sz="1900" b="1">
+                <a:solidFill>
+                  <a:srgbClr val="FFFFFF"/>
+                </a:solidFill>
+                <a:latin typeface="Arial"/>
+              </a:rPr>
+              <a:t>of the boards flagged by AOI are false calls</a:t>
+            </a:r>
+          </a:p>
+        </p:txBody>
+      </p:sp>
+      <p:sp>
+        <p:nvSpPr>
+          <p:cNvPr id="10" name="TextBox 9"/>
+          <p:cNvSpPr txBox="1"/>
+          <p:nvPr/>
+        </p:nvSpPr>
+        <p:spPr>
+          <a:xfrm>
+            <a:off x="1029599" y="4068000"/>
+            <a:ext cx="3024000" cy="576000"/>
+          </a:xfrm>
+          <a:prstGeom prst="rect">
+            <a:avLst/>
+          </a:prstGeom>
+          <a:noFill/>
+        </p:spPr>
+        <p:txBody>
+          <a:bodyPr wrap="square">
+            <a:spAutoFit/>
+          </a:bodyPr>
+          <a:lstStyle/>
+          <a:p>
+            <a:pPr>
+              <a:spcAft>
+                <a:spcPts val="400"/>
+              </a:spcAft>
+            </a:pPr>
+            <a:r>
               <a:rPr sz="1300" b="0">
                 <a:solidFill>
                   <a:srgbClr val="FFFFFF"/>
                 </a:solidFill>
                 <a:latin typeface="Arial"/>
               </a:rPr>
-              <a:t>of the boards flagged by the AOI machine are fine (false calls) in real Siemens production data.</a:t>
-            </a:r>
-          </a:p>
-          <a:p>
-            <a:pPr>
-              <a:spcAft>
-                <a:spcPts val="400"/>
-              </a:spcAft>
-            </a:pPr>
-            <a:r>
-              <a:rPr sz="1300" b="0">
-                <a:solidFill>
-                  <a:srgbClr val="FFFFFF"/>
-                </a:solidFill>
-                <a:latin typeface="Arial"/>
-              </a:rPr>
-              <a:t>Every flagged board goes to a manual inspection station.</a:t>
-            </a:r>
-          </a:p>
-        </p:txBody>
-      </p:sp>
-      <p:sp>
-        <p:nvSpPr>
-          <p:cNvPr id="10" name="Rounded Rectangle 9"/>
+              <a:t>Each one is checked again by hand at the manual inspection station.</a:t>
+            </a:r>
+          </a:p>
+        </p:txBody>
+      </p:sp>
+      <p:sp>
+        <p:nvSpPr>
+          <p:cNvPr id="11" name="TextBox 10"/>
+          <p:cNvSpPr txBox="1"/>
+          <p:nvPr/>
+        </p:nvSpPr>
+        <p:spPr>
+          <a:xfrm>
+            <a:off x="1029599" y="4752000"/>
+            <a:ext cx="3024000" cy="648000"/>
+          </a:xfrm>
+          <a:prstGeom prst="rect">
+            <a:avLst/>
+          </a:prstGeom>
+          <a:noFill/>
+        </p:spPr>
+        <p:txBody>
+          <a:bodyPr wrap="square">
+            <a:spAutoFit/>
+          </a:bodyPr>
+          <a:lstStyle/>
+          <a:p>
+            <a:pPr>
+              <a:spcAft>
+                <a:spcPts val="400"/>
+              </a:spcAft>
+            </a:pPr>
+            <a:r>
+              <a:rPr sz="1000" b="0">
+                <a:solidFill>
+                  <a:srgbClr val="B8C4D6"/>
+                </a:solidFill>
+                <a:latin typeface="Arial"/>
+              </a:rPr>
+              <a:t>Source: Siemens SMT line, Bavaria · 39,742 flagged boards, 132 days · Pfab et al. (2024), Data in Brief 53, 110110</a:t>
+            </a:r>
+          </a:p>
+        </p:txBody>
+      </p:sp>
+      <p:sp>
+        <p:nvSpPr>
+          <p:cNvPr id="12" name="Rounded Rectangle 11"/>
           <p:cNvSpPr/>
           <p:nvPr/>
         </p:nvSpPr>
@@ -7682,7 +7744,7 @@
       </p:sp>
       <p:sp>
         <p:nvSpPr>
-          <p:cNvPr id="11" name="TextBox 10"/>
+          <p:cNvPr id="13" name="TextBox 12"/>
           <p:cNvSpPr txBox="1"/>
           <p:nvPr/>
         </p:nvSpPr>
@@ -7721,7 +7783,7 @@
       </p:sp>
       <p:sp>
         <p:nvSpPr>
-          <p:cNvPr id="12" name="TextBox 11"/>
+          <p:cNvPr id="14" name="TextBox 13"/>
           <p:cNvSpPr txBox="1"/>
           <p:nvPr/>
         </p:nvSpPr>
@@ -7760,7 +7822,7 @@
       </p:sp>
       <p:sp>
         <p:nvSpPr>
-          <p:cNvPr id="13" name="Rounded Rectangle 12"/>
+          <p:cNvPr id="15" name="Rounded Rectangle 14"/>
           <p:cNvSpPr/>
           <p:nvPr/>
         </p:nvSpPr>
@@ -7806,7 +7868,7 @@
       </p:sp>
       <p:sp>
         <p:nvSpPr>
-          <p:cNvPr id="14" name="TextBox 13"/>
+          <p:cNvPr id="16" name="TextBox 15"/>
           <p:cNvSpPr txBox="1"/>
           <p:nvPr/>
         </p:nvSpPr>
@@ -7845,7 +7907,7 @@
       </p:sp>
       <p:sp>
         <p:nvSpPr>
-          <p:cNvPr id="15" name="TextBox 14"/>
+          <p:cNvPr id="17" name="TextBox 16"/>
           <p:cNvSpPr txBox="1"/>
           <p:nvPr/>
         </p:nvSpPr>
@@ -7884,7 +7946,7 @@
       </p:sp>
       <p:sp>
         <p:nvSpPr>
-          <p:cNvPr id="16" name="Rounded Rectangle 15"/>
+          <p:cNvPr id="18" name="Rounded Rectangle 17"/>
           <p:cNvSpPr/>
           <p:nvPr/>
         </p:nvSpPr>
@@ -7930,7 +7992,7 @@
       </p:sp>
       <p:sp>
         <p:nvSpPr>
-          <p:cNvPr id="17" name="TextBox 16"/>
+          <p:cNvPr id="19" name="TextBox 18"/>
           <p:cNvSpPr txBox="1"/>
           <p:nvPr/>
         </p:nvSpPr>
@@ -7969,7 +8031,7 @@
       </p:sp>
       <p:sp>
         <p:nvSpPr>
-          <p:cNvPr id="18" name="TextBox 17"/>
+          <p:cNvPr id="20" name="TextBox 19"/>
           <p:cNvSpPr txBox="1"/>
           <p:nvPr/>
         </p:nvSpPr>
@@ -9773,7 +9835,7 @@
                 </a:solidFill>
                 <a:latin typeface="Arial"/>
               </a:rPr>
-              <a:t>Training three classifiers</a:t>
+              <a:t>Training and comparing three classification models</a:t>
             </a:r>
           </a:p>
           <a:p>
@@ -10463,7 +10525,7 @@
                 </a:solidFill>
                 <a:latin typeface="Arial"/>
               </a:rPr>
-              <a:t>Reduce false calls: train three classifiers to separate false calls from true defects.</a:t>
+              <a:t>Reduce false calls: train three classification models (logistic regression, random forest, neural network) for the same binary task.</a:t>
             </a:r>
           </a:p>
         </p:txBody>
@@ -12449,7 +12511,7 @@
                 </a:solidFill>
                 <a:latin typeface="Arial"/>
               </a:rPr>
-              <a:t>3 models</a:t>
+              <a:t>3 models, compared</a:t>
             </a:r>
           </a:p>
         </p:txBody>
@@ -14257,7 +14319,7 @@
                 </a:solidFill>
                 <a:latin typeface="Arial"/>
               </a:rPr>
-              <a:t>Day-by-day simulation on recorded data: three classifiers</a:t>
+              <a:t>Day-by-day simulation on recorded data: three models compared</a:t>
             </a:r>
           </a:p>
         </p:txBody>

</xml_diff>

<commit_message>
Repository renamed to aoi-false-call-classification
</commit_message>
<xml_diff>
--- a/docs/slides_revised_topic.pptx
+++ b/docs/slides_revised_topic.pptx
@@ -3340,7 +3340,7 @@
                 </a:solidFill>
                 <a:latin typeface="Arial"/>
               </a:rPr>
-              <a:t>Team 1 · Guided by Dr. Hamidreza Heidari · 23 October 2026 · github.com/bodhi584/aoi-decision-gate</a:t>
+              <a:t>Team 1 · Guided by Dr. Hamidreza Heidari · 23 October 2026 · github.com/bodhi584/aoi-false-call-classification</a:t>
             </a:r>
           </a:p>
         </p:txBody>
@@ -7205,7 +7205,7 @@
                 </a:solidFill>
                 <a:latin typeface="Arial"/>
               </a:rPr>
-              <a:t>github.com/bodhi584/aoi-decision-gate</a:t>
+              <a:t>github.com/bodhi584/aoi-false-call-classification</a:t>
             </a:r>
           </a:p>
         </p:txBody>

</xml_diff>